<commit_message>
AI Update & Sanjay Addition
</commit_message>
<xml_diff>
--- a/KARMA_Cloud_SIEM_Presentation_v2.pptx
+++ b/KARMA_Cloud_SIEM_Presentation_v2.pptx
@@ -4,21 +4,24 @@
   <p:sldMasterIdLst>
     <p:sldMasterId id="2147483648" r:id="rId1"/>
   </p:sldMasterIdLst>
+  <p:notesMasterIdLst>
+    <p:notesMasterId r:id="rId14"/>
+  </p:notesMasterIdLst>
   <p:sldIdLst>
-    <p:sldId id="256" r:id="rId7"/>
-    <p:sldId id="257" r:id="rId8"/>
-    <p:sldId id="258" r:id="rId9"/>
-    <p:sldId id="259" r:id="rId10"/>
-    <p:sldId id="260" r:id="rId11"/>
-    <p:sldId id="261" r:id="rId12"/>
-    <p:sldId id="262" r:id="rId13"/>
-    <p:sldId id="263" r:id="rId14"/>
-    <p:sldId id="264" r:id="rId15"/>
-    <p:sldId id="265" r:id="rId16"/>
-    <p:sldId id="266" r:id="rId17"/>
-    <p:sldId id="267" r:id="rId18"/>
+    <p:sldId id="256" r:id="rId2"/>
+    <p:sldId id="257" r:id="rId3"/>
+    <p:sldId id="258" r:id="rId4"/>
+    <p:sldId id="259" r:id="rId5"/>
+    <p:sldId id="260" r:id="rId6"/>
+    <p:sldId id="261" r:id="rId7"/>
+    <p:sldId id="262" r:id="rId8"/>
+    <p:sldId id="263" r:id="rId9"/>
+    <p:sldId id="264" r:id="rId10"/>
+    <p:sldId id="265" r:id="rId11"/>
+    <p:sldId id="266" r:id="rId12"/>
+    <p:sldId id="267" r:id="rId13"/>
   </p:sldIdLst>
-  <p:sldSz cx="12191695" cy="6858000" type="screen4x3"/>
+  <p:sldSz cx="12192000" cy="6858000"/>
   <p:notesSz cx="6858000" cy="9144000"/>
   <p:defaultTextStyle>
     <a:defPPr>
@@ -115,7 +118,457 @@
       </a:defRPr>
     </a:lvl9pPr>
   </p:defaultTextStyle>
+  <p:extLst>
+    <p:ext uri="{EFAFB233-063F-42B5-8137-9DF3F51BA10A}">
+      <p15:sldGuideLst xmlns:p15="http://schemas.microsoft.com/office/powerpoint/2012/main">
+        <p15:guide id="1" orient="horz" pos="2160">
+          <p15:clr>
+            <a:srgbClr val="A4A3A4"/>
+          </p15:clr>
+        </p15:guide>
+        <p15:guide id="2" pos="2880">
+          <p15:clr>
+            <a:srgbClr val="A4A3A4"/>
+          </p15:clr>
+        </p15:guide>
+      </p15:sldGuideLst>
+    </p:ext>
+  </p:extLst>
 </p:presentation>
+</file>
+
+<file path=ppt/notesMasters/notesMaster1.xml><?xml version="1.0" encoding="utf-8"?>
+<p:notesMaster xmlns:a="http://schemas.openxmlformats.org/drawingml/2006/main" xmlns:r="http://schemas.openxmlformats.org/officeDocument/2006/relationships" xmlns:p="http://schemas.openxmlformats.org/presentationml/2006/main">
+  <p:cSld>
+    <p:bg>
+      <p:bgRef idx="1001">
+        <a:schemeClr val="bg1"/>
+      </p:bgRef>
+    </p:bg>
+    <p:spTree>
+      <p:nvGrpSpPr>
+        <p:cNvPr id="1" name=""/>
+        <p:cNvGrpSpPr/>
+        <p:nvPr/>
+      </p:nvGrpSpPr>
+      <p:grpSpPr>
+        <a:xfrm>
+          <a:off x="0" y="0"/>
+          <a:ext cx="0" cy="0"/>
+          <a:chOff x="0" y="0"/>
+          <a:chExt cx="0" cy="0"/>
+        </a:xfrm>
+      </p:grpSpPr>
+      <p:sp>
+        <p:nvSpPr>
+          <p:cNvPr id="2" name="Header Placeholder 1"/>
+          <p:cNvSpPr>
+            <a:spLocks noGrp="1"/>
+          </p:cNvSpPr>
+          <p:nvPr>
+            <p:ph type="hdr" sz="quarter"/>
+          </p:nvPr>
+        </p:nvSpPr>
+        <p:spPr>
+          <a:xfrm>
+            <a:off x="0" y="0"/>
+            <a:ext cx="2971800" cy="458788"/>
+          </a:xfrm>
+          <a:prstGeom prst="rect">
+            <a:avLst/>
+          </a:prstGeom>
+        </p:spPr>
+        <p:txBody>
+          <a:bodyPr vert="horz" lIns="91440" tIns="45720" rIns="91440" bIns="45720" rtlCol="0"/>
+          <a:lstStyle>
+            <a:lvl1pPr algn="l">
+              <a:defRPr sz="1200"/>
+            </a:lvl1pPr>
+          </a:lstStyle>
+          <a:p>
+            <a:endParaRPr lang="en-IN"/>
+          </a:p>
+        </p:txBody>
+      </p:sp>
+      <p:sp>
+        <p:nvSpPr>
+          <p:cNvPr id="3" name="Date Placeholder 2"/>
+          <p:cNvSpPr>
+            <a:spLocks noGrp="1"/>
+          </p:cNvSpPr>
+          <p:nvPr>
+            <p:ph type="dt" idx="1"/>
+          </p:nvPr>
+        </p:nvSpPr>
+        <p:spPr>
+          <a:xfrm>
+            <a:off x="3884613" y="0"/>
+            <a:ext cx="2971800" cy="458788"/>
+          </a:xfrm>
+          <a:prstGeom prst="rect">
+            <a:avLst/>
+          </a:prstGeom>
+        </p:spPr>
+        <p:txBody>
+          <a:bodyPr vert="horz" lIns="91440" tIns="45720" rIns="91440" bIns="45720" rtlCol="0"/>
+          <a:lstStyle>
+            <a:lvl1pPr algn="r">
+              <a:defRPr sz="1200"/>
+            </a:lvl1pPr>
+          </a:lstStyle>
+          <a:p>
+            <a:fld id="{21A417CE-DD9D-4A07-9A4F-CF7721CD7300}" type="datetimeFigureOut">
+              <a:rPr lang="en-IN" smtClean="0"/>
+              <a:t>24-08-2026</a:t>
+            </a:fld>
+            <a:endParaRPr lang="en-IN"/>
+          </a:p>
+        </p:txBody>
+      </p:sp>
+      <p:sp>
+        <p:nvSpPr>
+          <p:cNvPr id="4" name="Slide Image Placeholder 3"/>
+          <p:cNvSpPr>
+            <a:spLocks noGrp="1" noRot="1" noChangeAspect="1"/>
+          </p:cNvSpPr>
+          <p:nvPr>
+            <p:ph type="sldImg" idx="2"/>
+          </p:nvPr>
+        </p:nvSpPr>
+        <p:spPr>
+          <a:xfrm>
+            <a:off x="685800" y="1143000"/>
+            <a:ext cx="5486400" cy="3086100"/>
+          </a:xfrm>
+          <a:prstGeom prst="rect">
+            <a:avLst/>
+          </a:prstGeom>
+          <a:noFill/>
+          <a:ln w="12700">
+            <a:solidFill>
+              <a:prstClr val="black"/>
+            </a:solidFill>
+          </a:ln>
+        </p:spPr>
+        <p:txBody>
+          <a:bodyPr vert="horz" lIns="91440" tIns="45720" rIns="91440" bIns="45720" rtlCol="0" anchor="ctr"/>
+          <a:lstStyle/>
+          <a:p>
+            <a:endParaRPr lang="en-IN"/>
+          </a:p>
+        </p:txBody>
+      </p:sp>
+      <p:sp>
+        <p:nvSpPr>
+          <p:cNvPr id="5" name="Notes Placeholder 4"/>
+          <p:cNvSpPr>
+            <a:spLocks noGrp="1"/>
+          </p:cNvSpPr>
+          <p:nvPr>
+            <p:ph type="body" sz="quarter" idx="3"/>
+          </p:nvPr>
+        </p:nvSpPr>
+        <p:spPr>
+          <a:xfrm>
+            <a:off x="685800" y="4400550"/>
+            <a:ext cx="5486400" cy="3600450"/>
+          </a:xfrm>
+          <a:prstGeom prst="rect">
+            <a:avLst/>
+          </a:prstGeom>
+        </p:spPr>
+        <p:txBody>
+          <a:bodyPr vert="horz" lIns="91440" tIns="45720" rIns="91440" bIns="45720" rtlCol="0"/>
+          <a:lstStyle/>
+          <a:p>
+            <a:pPr lvl="0"/>
+            <a:r>
+              <a:rPr lang="en-US"/>
+              <a:t>Click to edit Master text styles</a:t>
+            </a:r>
+          </a:p>
+          <a:p>
+            <a:pPr lvl="1"/>
+            <a:r>
+              <a:rPr lang="en-US"/>
+              <a:t>Second level</a:t>
+            </a:r>
+          </a:p>
+          <a:p>
+            <a:pPr lvl="2"/>
+            <a:r>
+              <a:rPr lang="en-US"/>
+              <a:t>Third level</a:t>
+            </a:r>
+          </a:p>
+          <a:p>
+            <a:pPr lvl="3"/>
+            <a:r>
+              <a:rPr lang="en-US"/>
+              <a:t>Fourth level</a:t>
+            </a:r>
+          </a:p>
+          <a:p>
+            <a:pPr lvl="4"/>
+            <a:r>
+              <a:rPr lang="en-US"/>
+              <a:t>Fifth level</a:t>
+            </a:r>
+            <a:endParaRPr lang="en-IN"/>
+          </a:p>
+        </p:txBody>
+      </p:sp>
+      <p:sp>
+        <p:nvSpPr>
+          <p:cNvPr id="6" name="Footer Placeholder 5"/>
+          <p:cNvSpPr>
+            <a:spLocks noGrp="1"/>
+          </p:cNvSpPr>
+          <p:nvPr>
+            <p:ph type="ftr" sz="quarter" idx="4"/>
+          </p:nvPr>
+        </p:nvSpPr>
+        <p:spPr>
+          <a:xfrm>
+            <a:off x="0" y="8685213"/>
+            <a:ext cx="2971800" cy="458787"/>
+          </a:xfrm>
+          <a:prstGeom prst="rect">
+            <a:avLst/>
+          </a:prstGeom>
+        </p:spPr>
+        <p:txBody>
+          <a:bodyPr vert="horz" lIns="91440" tIns="45720" rIns="91440" bIns="45720" rtlCol="0" anchor="b"/>
+          <a:lstStyle>
+            <a:lvl1pPr algn="l">
+              <a:defRPr sz="1200"/>
+            </a:lvl1pPr>
+          </a:lstStyle>
+          <a:p>
+            <a:endParaRPr lang="en-IN"/>
+          </a:p>
+        </p:txBody>
+      </p:sp>
+      <p:sp>
+        <p:nvSpPr>
+          <p:cNvPr id="7" name="Slide Number Placeholder 6"/>
+          <p:cNvSpPr>
+            <a:spLocks noGrp="1"/>
+          </p:cNvSpPr>
+          <p:nvPr>
+            <p:ph type="sldNum" sz="quarter" idx="5"/>
+          </p:nvPr>
+        </p:nvSpPr>
+        <p:spPr>
+          <a:xfrm>
+            <a:off x="3884613" y="8685213"/>
+            <a:ext cx="2971800" cy="458787"/>
+          </a:xfrm>
+          <a:prstGeom prst="rect">
+            <a:avLst/>
+          </a:prstGeom>
+        </p:spPr>
+        <p:txBody>
+          <a:bodyPr vert="horz" lIns="91440" tIns="45720" rIns="91440" bIns="45720" rtlCol="0" anchor="b"/>
+          <a:lstStyle>
+            <a:lvl1pPr algn="r">
+              <a:defRPr sz="1200"/>
+            </a:lvl1pPr>
+          </a:lstStyle>
+          <a:p>
+            <a:fld id="{AECEBDBE-B206-46CD-B711-185508607896}" type="slidenum">
+              <a:rPr lang="en-IN" smtClean="0"/>
+              <a:t>‹#›</a:t>
+            </a:fld>
+            <a:endParaRPr lang="en-IN"/>
+          </a:p>
+        </p:txBody>
+      </p:sp>
+    </p:spTree>
+    <p:extLst>
+      <p:ext uri="{BB962C8B-B14F-4D97-AF65-F5344CB8AC3E}">
+        <p14:creationId xmlns:p14="http://schemas.microsoft.com/office/powerpoint/2010/main" val="3691351424"/>
+      </p:ext>
+    </p:extLst>
+  </p:cSld>
+  <p:clrMap bg1="lt1" tx1="dk1" bg2="lt2" tx2="dk2" accent1="accent1" accent2="accent2" accent3="accent3" accent4="accent4" accent5="accent5" accent6="accent6" hlink="hlink" folHlink="folHlink"/>
+  <p:notesStyle>
+    <a:lvl1pPr marL="0" algn="l" defTabSz="914400" rtl="0" eaLnBrk="1" latinLnBrk="0" hangingPunct="1">
+      <a:defRPr sz="1200" kern="1200">
+        <a:solidFill>
+          <a:schemeClr val="tx1"/>
+        </a:solidFill>
+        <a:latin typeface="+mn-lt"/>
+        <a:ea typeface="+mn-ea"/>
+        <a:cs typeface="+mn-cs"/>
+      </a:defRPr>
+    </a:lvl1pPr>
+    <a:lvl2pPr marL="457200" algn="l" defTabSz="914400" rtl="0" eaLnBrk="1" latinLnBrk="0" hangingPunct="1">
+      <a:defRPr sz="1200" kern="1200">
+        <a:solidFill>
+          <a:schemeClr val="tx1"/>
+        </a:solidFill>
+        <a:latin typeface="+mn-lt"/>
+        <a:ea typeface="+mn-ea"/>
+        <a:cs typeface="+mn-cs"/>
+      </a:defRPr>
+    </a:lvl2pPr>
+    <a:lvl3pPr marL="914400" algn="l" defTabSz="914400" rtl="0" eaLnBrk="1" latinLnBrk="0" hangingPunct="1">
+      <a:defRPr sz="1200" kern="1200">
+        <a:solidFill>
+          <a:schemeClr val="tx1"/>
+        </a:solidFill>
+        <a:latin typeface="+mn-lt"/>
+        <a:ea typeface="+mn-ea"/>
+        <a:cs typeface="+mn-cs"/>
+      </a:defRPr>
+    </a:lvl3pPr>
+    <a:lvl4pPr marL="1371600" algn="l" defTabSz="914400" rtl="0" eaLnBrk="1" latinLnBrk="0" hangingPunct="1">
+      <a:defRPr sz="1200" kern="1200">
+        <a:solidFill>
+          <a:schemeClr val="tx1"/>
+        </a:solidFill>
+        <a:latin typeface="+mn-lt"/>
+        <a:ea typeface="+mn-ea"/>
+        <a:cs typeface="+mn-cs"/>
+      </a:defRPr>
+    </a:lvl4pPr>
+    <a:lvl5pPr marL="1828800" algn="l" defTabSz="914400" rtl="0" eaLnBrk="1" latinLnBrk="0" hangingPunct="1">
+      <a:defRPr sz="1200" kern="1200">
+        <a:solidFill>
+          <a:schemeClr val="tx1"/>
+        </a:solidFill>
+        <a:latin typeface="+mn-lt"/>
+        <a:ea typeface="+mn-ea"/>
+        <a:cs typeface="+mn-cs"/>
+      </a:defRPr>
+    </a:lvl5pPr>
+    <a:lvl6pPr marL="2286000" algn="l" defTabSz="914400" rtl="0" eaLnBrk="1" latinLnBrk="0" hangingPunct="1">
+      <a:defRPr sz="1200" kern="1200">
+        <a:solidFill>
+          <a:schemeClr val="tx1"/>
+        </a:solidFill>
+        <a:latin typeface="+mn-lt"/>
+        <a:ea typeface="+mn-ea"/>
+        <a:cs typeface="+mn-cs"/>
+      </a:defRPr>
+    </a:lvl6pPr>
+    <a:lvl7pPr marL="2743200" algn="l" defTabSz="914400" rtl="0" eaLnBrk="1" latinLnBrk="0" hangingPunct="1">
+      <a:defRPr sz="1200" kern="1200">
+        <a:solidFill>
+          <a:schemeClr val="tx1"/>
+        </a:solidFill>
+        <a:latin typeface="+mn-lt"/>
+        <a:ea typeface="+mn-ea"/>
+        <a:cs typeface="+mn-cs"/>
+      </a:defRPr>
+    </a:lvl7pPr>
+    <a:lvl8pPr marL="3200400" algn="l" defTabSz="914400" rtl="0" eaLnBrk="1" latinLnBrk="0" hangingPunct="1">
+      <a:defRPr sz="1200" kern="1200">
+        <a:solidFill>
+          <a:schemeClr val="tx1"/>
+        </a:solidFill>
+        <a:latin typeface="+mn-lt"/>
+        <a:ea typeface="+mn-ea"/>
+        <a:cs typeface="+mn-cs"/>
+      </a:defRPr>
+    </a:lvl8pPr>
+    <a:lvl9pPr marL="3657600" algn="l" defTabSz="914400" rtl="0" eaLnBrk="1" latinLnBrk="0" hangingPunct="1">
+      <a:defRPr sz="1200" kern="1200">
+        <a:solidFill>
+          <a:schemeClr val="tx1"/>
+        </a:solidFill>
+        <a:latin typeface="+mn-lt"/>
+        <a:ea typeface="+mn-ea"/>
+        <a:cs typeface="+mn-cs"/>
+      </a:defRPr>
+    </a:lvl9pPr>
+  </p:notesStyle>
+</p:notesMaster>
+</file>
+
+<file path=ppt/notesSlides/notesSlide1.xml><?xml version="1.0" encoding="utf-8"?>
+<p:notes xmlns:a="http://schemas.openxmlformats.org/drawingml/2006/main" xmlns:r="http://schemas.openxmlformats.org/officeDocument/2006/relationships" xmlns:p="http://schemas.openxmlformats.org/presentationml/2006/main">
+  <p:cSld>
+    <p:spTree>
+      <p:nvGrpSpPr>
+        <p:cNvPr id="1" name=""/>
+        <p:cNvGrpSpPr/>
+        <p:nvPr/>
+      </p:nvGrpSpPr>
+      <p:grpSpPr>
+        <a:xfrm>
+          <a:off x="0" y="0"/>
+          <a:ext cx="0" cy="0"/>
+          <a:chOff x="0" y="0"/>
+          <a:chExt cx="0" cy="0"/>
+        </a:xfrm>
+      </p:grpSpPr>
+      <p:sp>
+        <p:nvSpPr>
+          <p:cNvPr id="2" name="Slide Image Placeholder 1"/>
+          <p:cNvSpPr>
+            <a:spLocks noGrp="1" noRot="1" noChangeAspect="1"/>
+          </p:cNvSpPr>
+          <p:nvPr>
+            <p:ph type="sldImg"/>
+          </p:nvPr>
+        </p:nvSpPr>
+        <p:spPr/>
+      </p:sp>
+      <p:sp>
+        <p:nvSpPr>
+          <p:cNvPr id="3" name="Notes Placeholder 2"/>
+          <p:cNvSpPr>
+            <a:spLocks noGrp="1"/>
+          </p:cNvSpPr>
+          <p:nvPr>
+            <p:ph type="body" idx="1"/>
+          </p:nvPr>
+        </p:nvSpPr>
+        <p:spPr/>
+        <p:txBody>
+          <a:bodyPr/>
+          <a:lstStyle/>
+          <a:p>
+            <a:endParaRPr lang="en-IN" dirty="0"/>
+          </a:p>
+        </p:txBody>
+      </p:sp>
+      <p:sp>
+        <p:nvSpPr>
+          <p:cNvPr id="4" name="Slide Number Placeholder 3"/>
+          <p:cNvSpPr>
+            <a:spLocks noGrp="1"/>
+          </p:cNvSpPr>
+          <p:nvPr>
+            <p:ph type="sldNum" sz="quarter" idx="5"/>
+          </p:nvPr>
+        </p:nvSpPr>
+        <p:spPr/>
+        <p:txBody>
+          <a:bodyPr/>
+          <a:lstStyle/>
+          <a:p>
+            <a:fld id="{AECEBDBE-B206-46CD-B711-185508607896}" type="slidenum">
+              <a:rPr lang="en-IN" smtClean="0"/>
+              <a:t>5</a:t>
+            </a:fld>
+            <a:endParaRPr lang="en-IN"/>
+          </a:p>
+        </p:txBody>
+      </p:sp>
+    </p:spTree>
+    <p:extLst>
+      <p:ext uri="{BB962C8B-B14F-4D97-AF65-F5344CB8AC3E}">
+        <p14:creationId xmlns:p14="http://schemas.microsoft.com/office/powerpoint/2010/main" val="2255801249"/>
+      </p:ext>
+    </p:extLst>
+  </p:cSld>
+  <p:clrMapOvr>
+    <a:masterClrMapping/>
+  </p:clrMapOvr>
+</p:notes>
 </file>
 
 <file path=ppt/slideLayouts/slideLayout1.xml><?xml version="1.0" encoding="utf-8"?>
@@ -156,10 +609,9 @@
           <a:lstStyle/>
           <a:p>
             <a:r>
-              <a:rPr lang="en-US" smtClean="0"/>
+              <a:rPr lang="en-US"/>
               <a:t>Click to edit Master title style</a:t>
             </a:r>
-            <a:endParaRPr lang="en-US"/>
           </a:p>
         </p:txBody>
       </p:sp>
@@ -275,10 +727,9 @@
           </a:lstStyle>
           <a:p>
             <a:r>
-              <a:rPr lang="en-US" smtClean="0"/>
+              <a:rPr lang="en-US"/>
               <a:t>Click to edit Master subtitle style</a:t>
             </a:r>
-            <a:endParaRPr lang="en-US"/>
           </a:p>
         </p:txBody>
       </p:sp>
@@ -299,7 +750,7 @@
           <a:p>
             <a:fld id="{5BCAD085-E8A6-8845-BD4E-CB4CCA059FC4}" type="datetimeFigureOut">
               <a:rPr lang="en-US" smtClean="0"/>
-              <a:t>1/27/13</a:t>
+              <a:t>8/24/2026</a:t>
             </a:fld>
             <a:endParaRPr lang="en-US"/>
           </a:p>
@@ -393,10 +844,9 @@
           <a:lstStyle/>
           <a:p>
             <a:r>
-              <a:rPr lang="en-US" smtClean="0"/>
+              <a:rPr lang="en-US"/>
               <a:t>Click to edit Master title style</a:t>
             </a:r>
-            <a:endParaRPr lang="en-US"/>
           </a:p>
         </p:txBody>
       </p:sp>
@@ -417,38 +867,37 @@
           <a:p>
             <a:pPr lvl="0"/>
             <a:r>
-              <a:rPr lang="en-US" smtClean="0"/>
+              <a:rPr lang="en-US"/>
               <a:t>Click to edit Master text styles</a:t>
             </a:r>
           </a:p>
           <a:p>
             <a:pPr lvl="1"/>
             <a:r>
-              <a:rPr lang="en-US" smtClean="0"/>
+              <a:rPr lang="en-US"/>
               <a:t>Second level</a:t>
             </a:r>
           </a:p>
           <a:p>
             <a:pPr lvl="2"/>
             <a:r>
-              <a:rPr lang="en-US" smtClean="0"/>
+              <a:rPr lang="en-US"/>
               <a:t>Third level</a:t>
             </a:r>
           </a:p>
           <a:p>
             <a:pPr lvl="3"/>
             <a:r>
-              <a:rPr lang="en-US" smtClean="0"/>
+              <a:rPr lang="en-US"/>
               <a:t>Fourth level</a:t>
             </a:r>
           </a:p>
           <a:p>
             <a:pPr lvl="4"/>
             <a:r>
-              <a:rPr lang="en-US" smtClean="0"/>
+              <a:rPr lang="en-US"/>
               <a:t>Fifth level</a:t>
             </a:r>
-            <a:endParaRPr lang="en-US"/>
           </a:p>
         </p:txBody>
       </p:sp>
@@ -469,7 +918,7 @@
           <a:p>
             <a:fld id="{5BCAD085-E8A6-8845-BD4E-CB4CCA059FC4}" type="datetimeFigureOut">
               <a:rPr lang="en-US" smtClean="0"/>
-              <a:t>1/27/13</a:t>
+              <a:t>8/24/2026</a:t>
             </a:fld>
             <a:endParaRPr lang="en-US"/>
           </a:p>
@@ -568,10 +1017,9 @@
           <a:lstStyle/>
           <a:p>
             <a:r>
-              <a:rPr lang="en-US" smtClean="0"/>
+              <a:rPr lang="en-US"/>
               <a:t>Click to edit Master title style</a:t>
             </a:r>
-            <a:endParaRPr lang="en-US"/>
           </a:p>
         </p:txBody>
       </p:sp>
@@ -597,38 +1045,37 @@
           <a:p>
             <a:pPr lvl="0"/>
             <a:r>
-              <a:rPr lang="en-US" smtClean="0"/>
+              <a:rPr lang="en-US"/>
               <a:t>Click to edit Master text styles</a:t>
             </a:r>
           </a:p>
           <a:p>
             <a:pPr lvl="1"/>
             <a:r>
-              <a:rPr lang="en-US" smtClean="0"/>
+              <a:rPr lang="en-US"/>
               <a:t>Second level</a:t>
             </a:r>
           </a:p>
           <a:p>
             <a:pPr lvl="2"/>
             <a:r>
-              <a:rPr lang="en-US" smtClean="0"/>
+              <a:rPr lang="en-US"/>
               <a:t>Third level</a:t>
             </a:r>
           </a:p>
           <a:p>
             <a:pPr lvl="3"/>
             <a:r>
-              <a:rPr lang="en-US" smtClean="0"/>
+              <a:rPr lang="en-US"/>
               <a:t>Fourth level</a:t>
             </a:r>
           </a:p>
           <a:p>
             <a:pPr lvl="4"/>
             <a:r>
-              <a:rPr lang="en-US" smtClean="0"/>
+              <a:rPr lang="en-US"/>
               <a:t>Fifth level</a:t>
             </a:r>
-            <a:endParaRPr lang="en-US"/>
           </a:p>
         </p:txBody>
       </p:sp>
@@ -649,7 +1096,7 @@
           <a:p>
             <a:fld id="{5BCAD085-E8A6-8845-BD4E-CB4CCA059FC4}" type="datetimeFigureOut">
               <a:rPr lang="en-US" smtClean="0"/>
-              <a:t>1/27/13</a:t>
+              <a:t>8/24/2026</a:t>
             </a:fld>
             <a:endParaRPr lang="en-US"/>
           </a:p>
@@ -743,10 +1190,9 @@
           <a:lstStyle/>
           <a:p>
             <a:r>
-              <a:rPr lang="en-US" smtClean="0"/>
+              <a:rPr lang="en-US"/>
               <a:t>Click to edit Master title style</a:t>
             </a:r>
-            <a:endParaRPr lang="en-US"/>
           </a:p>
         </p:txBody>
       </p:sp>
@@ -767,38 +1213,37 @@
           <a:p>
             <a:pPr lvl="0"/>
             <a:r>
-              <a:rPr lang="en-US" smtClean="0"/>
+              <a:rPr lang="en-US"/>
               <a:t>Click to edit Master text styles</a:t>
             </a:r>
           </a:p>
           <a:p>
             <a:pPr lvl="1"/>
             <a:r>
-              <a:rPr lang="en-US" smtClean="0"/>
+              <a:rPr lang="en-US"/>
               <a:t>Second level</a:t>
             </a:r>
           </a:p>
           <a:p>
             <a:pPr lvl="2"/>
             <a:r>
-              <a:rPr lang="en-US" smtClean="0"/>
+              <a:rPr lang="en-US"/>
               <a:t>Third level</a:t>
             </a:r>
           </a:p>
           <a:p>
             <a:pPr lvl="3"/>
             <a:r>
-              <a:rPr lang="en-US" smtClean="0"/>
+              <a:rPr lang="en-US"/>
               <a:t>Fourth level</a:t>
             </a:r>
           </a:p>
           <a:p>
             <a:pPr lvl="4"/>
             <a:r>
-              <a:rPr lang="en-US" smtClean="0"/>
+              <a:rPr lang="en-US"/>
               <a:t>Fifth level</a:t>
             </a:r>
-            <a:endParaRPr lang="en-US"/>
           </a:p>
         </p:txBody>
       </p:sp>
@@ -819,7 +1264,7 @@
           <a:p>
             <a:fld id="{5BCAD085-E8A6-8845-BD4E-CB4CCA059FC4}" type="datetimeFigureOut">
               <a:rPr lang="en-US" smtClean="0"/>
-              <a:t>1/27/13</a:t>
+              <a:t>8/24/2026</a:t>
             </a:fld>
             <a:endParaRPr lang="en-US"/>
           </a:p>
@@ -922,10 +1367,9 @@
           </a:lstStyle>
           <a:p>
             <a:r>
-              <a:rPr lang="en-US" smtClean="0"/>
+              <a:rPr lang="en-US"/>
               <a:t>Click to edit Master title style</a:t>
             </a:r>
-            <a:endParaRPr lang="en-US"/>
           </a:p>
         </p:txBody>
       </p:sp>
@@ -1042,7 +1486,7 @@
           <a:p>
             <a:pPr lvl="0"/>
             <a:r>
-              <a:rPr lang="en-US" smtClean="0"/>
+              <a:rPr lang="en-US"/>
               <a:t>Click to edit Master text styles</a:t>
             </a:r>
           </a:p>
@@ -1065,7 +1509,7 @@
           <a:p>
             <a:fld id="{5BCAD085-E8A6-8845-BD4E-CB4CCA059FC4}" type="datetimeFigureOut">
               <a:rPr lang="en-US" smtClean="0"/>
-              <a:t>1/27/13</a:t>
+              <a:t>8/24/2026</a:t>
             </a:fld>
             <a:endParaRPr lang="en-US"/>
           </a:p>
@@ -1159,10 +1603,9 @@
           <a:lstStyle/>
           <a:p>
             <a:r>
-              <a:rPr lang="en-US" smtClean="0"/>
+              <a:rPr lang="en-US"/>
               <a:t>Click to edit Master title style</a:t>
             </a:r>
-            <a:endParaRPr lang="en-US"/>
           </a:p>
         </p:txBody>
       </p:sp>
@@ -1216,38 +1659,37 @@
           <a:p>
             <a:pPr lvl="0"/>
             <a:r>
-              <a:rPr lang="en-US" smtClean="0"/>
+              <a:rPr lang="en-US"/>
               <a:t>Click to edit Master text styles</a:t>
             </a:r>
           </a:p>
           <a:p>
             <a:pPr lvl="1"/>
             <a:r>
-              <a:rPr lang="en-US" smtClean="0"/>
+              <a:rPr lang="en-US"/>
               <a:t>Second level</a:t>
             </a:r>
           </a:p>
           <a:p>
             <a:pPr lvl="2"/>
             <a:r>
-              <a:rPr lang="en-US" smtClean="0"/>
+              <a:rPr lang="en-US"/>
               <a:t>Third level</a:t>
             </a:r>
           </a:p>
           <a:p>
             <a:pPr lvl="3"/>
             <a:r>
-              <a:rPr lang="en-US" smtClean="0"/>
+              <a:rPr lang="en-US"/>
               <a:t>Fourth level</a:t>
             </a:r>
           </a:p>
           <a:p>
             <a:pPr lvl="4"/>
             <a:r>
-              <a:rPr lang="en-US" smtClean="0"/>
+              <a:rPr lang="en-US"/>
               <a:t>Fifth level</a:t>
             </a:r>
-            <a:endParaRPr lang="en-US"/>
           </a:p>
         </p:txBody>
       </p:sp>
@@ -1301,38 +1743,37 @@
           <a:p>
             <a:pPr lvl="0"/>
             <a:r>
-              <a:rPr lang="en-US" smtClean="0"/>
+              <a:rPr lang="en-US"/>
               <a:t>Click to edit Master text styles</a:t>
             </a:r>
           </a:p>
           <a:p>
             <a:pPr lvl="1"/>
             <a:r>
-              <a:rPr lang="en-US" smtClean="0"/>
+              <a:rPr lang="en-US"/>
               <a:t>Second level</a:t>
             </a:r>
           </a:p>
           <a:p>
             <a:pPr lvl="2"/>
             <a:r>
-              <a:rPr lang="en-US" smtClean="0"/>
+              <a:rPr lang="en-US"/>
               <a:t>Third level</a:t>
             </a:r>
           </a:p>
           <a:p>
             <a:pPr lvl="3"/>
             <a:r>
-              <a:rPr lang="en-US" smtClean="0"/>
+              <a:rPr lang="en-US"/>
               <a:t>Fourth level</a:t>
             </a:r>
           </a:p>
           <a:p>
             <a:pPr lvl="4"/>
             <a:r>
-              <a:rPr lang="en-US" smtClean="0"/>
+              <a:rPr lang="en-US"/>
               <a:t>Fifth level</a:t>
             </a:r>
-            <a:endParaRPr lang="en-US"/>
           </a:p>
         </p:txBody>
       </p:sp>
@@ -1353,7 +1794,7 @@
           <a:p>
             <a:fld id="{5BCAD085-E8A6-8845-BD4E-CB4CCA059FC4}" type="datetimeFigureOut">
               <a:rPr lang="en-US" smtClean="0"/>
-              <a:t>1/27/13</a:t>
+              <a:t>8/24/2026</a:t>
             </a:fld>
             <a:endParaRPr lang="en-US"/>
           </a:p>
@@ -1451,10 +1892,9 @@
           </a:lstStyle>
           <a:p>
             <a:r>
-              <a:rPr lang="en-US" smtClean="0"/>
+              <a:rPr lang="en-US"/>
               <a:t>Click to edit Master title style</a:t>
             </a:r>
-            <a:endParaRPr lang="en-US"/>
           </a:p>
         </p:txBody>
       </p:sp>
@@ -1517,7 +1957,7 @@
           <a:p>
             <a:pPr lvl="0"/>
             <a:r>
-              <a:rPr lang="en-US" smtClean="0"/>
+              <a:rPr lang="en-US"/>
               <a:t>Click to edit Master text styles</a:t>
             </a:r>
           </a:p>
@@ -1573,38 +2013,37 @@
           <a:p>
             <a:pPr lvl="0"/>
             <a:r>
-              <a:rPr lang="en-US" smtClean="0"/>
+              <a:rPr lang="en-US"/>
               <a:t>Click to edit Master text styles</a:t>
             </a:r>
           </a:p>
           <a:p>
             <a:pPr lvl="1"/>
             <a:r>
-              <a:rPr lang="en-US" smtClean="0"/>
+              <a:rPr lang="en-US"/>
               <a:t>Second level</a:t>
             </a:r>
           </a:p>
           <a:p>
             <a:pPr lvl="2"/>
             <a:r>
-              <a:rPr lang="en-US" smtClean="0"/>
+              <a:rPr lang="en-US"/>
               <a:t>Third level</a:t>
             </a:r>
           </a:p>
           <a:p>
             <a:pPr lvl="3"/>
             <a:r>
-              <a:rPr lang="en-US" smtClean="0"/>
+              <a:rPr lang="en-US"/>
               <a:t>Fourth level</a:t>
             </a:r>
           </a:p>
           <a:p>
             <a:pPr lvl="4"/>
             <a:r>
-              <a:rPr lang="en-US" smtClean="0"/>
+              <a:rPr lang="en-US"/>
               <a:t>Fifth level</a:t>
             </a:r>
-            <a:endParaRPr lang="en-US"/>
           </a:p>
         </p:txBody>
       </p:sp>
@@ -1667,7 +2106,7 @@
           <a:p>
             <a:pPr lvl="0"/>
             <a:r>
-              <a:rPr lang="en-US" smtClean="0"/>
+              <a:rPr lang="en-US"/>
               <a:t>Click to edit Master text styles</a:t>
             </a:r>
           </a:p>
@@ -1723,38 +2162,37 @@
           <a:p>
             <a:pPr lvl="0"/>
             <a:r>
-              <a:rPr lang="en-US" smtClean="0"/>
+              <a:rPr lang="en-US"/>
               <a:t>Click to edit Master text styles</a:t>
             </a:r>
           </a:p>
           <a:p>
             <a:pPr lvl="1"/>
             <a:r>
-              <a:rPr lang="en-US" smtClean="0"/>
+              <a:rPr lang="en-US"/>
               <a:t>Second level</a:t>
             </a:r>
           </a:p>
           <a:p>
             <a:pPr lvl="2"/>
             <a:r>
-              <a:rPr lang="en-US" smtClean="0"/>
+              <a:rPr lang="en-US"/>
               <a:t>Third level</a:t>
             </a:r>
           </a:p>
           <a:p>
             <a:pPr lvl="3"/>
             <a:r>
-              <a:rPr lang="en-US" smtClean="0"/>
+              <a:rPr lang="en-US"/>
               <a:t>Fourth level</a:t>
             </a:r>
           </a:p>
           <a:p>
             <a:pPr lvl="4"/>
             <a:r>
-              <a:rPr lang="en-US" smtClean="0"/>
+              <a:rPr lang="en-US"/>
               <a:t>Fifth level</a:t>
             </a:r>
-            <a:endParaRPr lang="en-US"/>
           </a:p>
         </p:txBody>
       </p:sp>
@@ -1775,7 +2213,7 @@
           <a:p>
             <a:fld id="{5BCAD085-E8A6-8845-BD4E-CB4CCA059FC4}" type="datetimeFigureOut">
               <a:rPr lang="en-US" smtClean="0"/>
-              <a:t>1/27/13</a:t>
+              <a:t>8/24/2026</a:t>
             </a:fld>
             <a:endParaRPr lang="en-US"/>
           </a:p>
@@ -1869,10 +2307,9 @@
           <a:lstStyle/>
           <a:p>
             <a:r>
-              <a:rPr lang="en-US" smtClean="0"/>
+              <a:rPr lang="en-US"/>
               <a:t>Click to edit Master title style</a:t>
             </a:r>
-            <a:endParaRPr lang="en-US"/>
           </a:p>
         </p:txBody>
       </p:sp>
@@ -1893,7 +2330,7 @@
           <a:p>
             <a:fld id="{5BCAD085-E8A6-8845-BD4E-CB4CCA059FC4}" type="datetimeFigureOut">
               <a:rPr lang="en-US" smtClean="0"/>
-              <a:t>1/27/13</a:t>
+              <a:t>8/24/2026</a:t>
             </a:fld>
             <a:endParaRPr lang="en-US"/>
           </a:p>
@@ -1988,7 +2425,7 @@
           <a:p>
             <a:fld id="{5BCAD085-E8A6-8845-BD4E-CB4CCA059FC4}" type="datetimeFigureOut">
               <a:rPr lang="en-US" smtClean="0"/>
-              <a:t>1/27/13</a:t>
+              <a:t>8/24/2026</a:t>
             </a:fld>
             <a:endParaRPr lang="en-US"/>
           </a:p>
@@ -2091,10 +2528,9 @@
           </a:lstStyle>
           <a:p>
             <a:r>
-              <a:rPr lang="en-US" smtClean="0"/>
+              <a:rPr lang="en-US"/>
               <a:t>Click to edit Master title style</a:t>
             </a:r>
-            <a:endParaRPr lang="en-US"/>
           </a:p>
         </p:txBody>
       </p:sp>
@@ -2148,38 +2584,37 @@
           <a:p>
             <a:pPr lvl="0"/>
             <a:r>
-              <a:rPr lang="en-US" smtClean="0"/>
+              <a:rPr lang="en-US"/>
               <a:t>Click to edit Master text styles</a:t>
             </a:r>
           </a:p>
           <a:p>
             <a:pPr lvl="1"/>
             <a:r>
-              <a:rPr lang="en-US" smtClean="0"/>
+              <a:rPr lang="en-US"/>
               <a:t>Second level</a:t>
             </a:r>
           </a:p>
           <a:p>
             <a:pPr lvl="2"/>
             <a:r>
-              <a:rPr lang="en-US" smtClean="0"/>
+              <a:rPr lang="en-US"/>
               <a:t>Third level</a:t>
             </a:r>
           </a:p>
           <a:p>
             <a:pPr lvl="3"/>
             <a:r>
-              <a:rPr lang="en-US" smtClean="0"/>
+              <a:rPr lang="en-US"/>
               <a:t>Fourth level</a:t>
             </a:r>
           </a:p>
           <a:p>
             <a:pPr lvl="4"/>
             <a:r>
-              <a:rPr lang="en-US" smtClean="0"/>
+              <a:rPr lang="en-US"/>
               <a:t>Fifth level</a:t>
             </a:r>
-            <a:endParaRPr lang="en-US"/>
           </a:p>
         </p:txBody>
       </p:sp>
@@ -2242,7 +2677,7 @@
           <a:p>
             <a:pPr lvl="0"/>
             <a:r>
-              <a:rPr lang="en-US" smtClean="0"/>
+              <a:rPr lang="en-US"/>
               <a:t>Click to edit Master text styles</a:t>
             </a:r>
           </a:p>
@@ -2265,7 +2700,7 @@
           <a:p>
             <a:fld id="{5BCAD085-E8A6-8845-BD4E-CB4CCA059FC4}" type="datetimeFigureOut">
               <a:rPr lang="en-US" smtClean="0"/>
-              <a:t>1/27/13</a:t>
+              <a:t>8/24/2026</a:t>
             </a:fld>
             <a:endParaRPr lang="en-US"/>
           </a:p>
@@ -2368,10 +2803,9 @@
           </a:lstStyle>
           <a:p>
             <a:r>
-              <a:rPr lang="en-US" smtClean="0"/>
+              <a:rPr lang="en-US"/>
               <a:t>Click to edit Master title style</a:t>
             </a:r>
-            <a:endParaRPr lang="en-US"/>
           </a:p>
         </p:txBody>
       </p:sp>
@@ -2495,7 +2929,7 @@
           <a:p>
             <a:pPr lvl="0"/>
             <a:r>
-              <a:rPr lang="en-US" smtClean="0"/>
+              <a:rPr lang="en-US"/>
               <a:t>Click to edit Master text styles</a:t>
             </a:r>
           </a:p>
@@ -2518,7 +2952,7 @@
           <a:p>
             <a:fld id="{5BCAD085-E8A6-8845-BD4E-CB4CCA059FC4}" type="datetimeFigureOut">
               <a:rPr lang="en-US" smtClean="0"/>
-              <a:t>1/27/13</a:t>
+              <a:t>8/24/2026</a:t>
             </a:fld>
             <a:endParaRPr lang="en-US"/>
           </a:p>
@@ -2627,10 +3061,9 @@
           <a:lstStyle/>
           <a:p>
             <a:r>
-              <a:rPr lang="en-US" smtClean="0"/>
+              <a:rPr lang="en-US"/>
               <a:t>Click to edit Master title style</a:t>
             </a:r>
-            <a:endParaRPr lang="en-US"/>
           </a:p>
         </p:txBody>
       </p:sp>
@@ -2661,38 +3094,37 @@
           <a:p>
             <a:pPr lvl="0"/>
             <a:r>
-              <a:rPr lang="en-US" smtClean="0"/>
+              <a:rPr lang="en-US"/>
               <a:t>Click to edit Master text styles</a:t>
             </a:r>
           </a:p>
           <a:p>
             <a:pPr lvl="1"/>
             <a:r>
-              <a:rPr lang="en-US" smtClean="0"/>
+              <a:rPr lang="en-US"/>
               <a:t>Second level</a:t>
             </a:r>
           </a:p>
           <a:p>
             <a:pPr lvl="2"/>
             <a:r>
-              <a:rPr lang="en-US" smtClean="0"/>
+              <a:rPr lang="en-US"/>
               <a:t>Third level</a:t>
             </a:r>
           </a:p>
           <a:p>
             <a:pPr lvl="3"/>
             <a:r>
-              <a:rPr lang="en-US" smtClean="0"/>
+              <a:rPr lang="en-US"/>
               <a:t>Fourth level</a:t>
             </a:r>
           </a:p>
           <a:p>
             <a:pPr lvl="4"/>
             <a:r>
-              <a:rPr lang="en-US" smtClean="0"/>
+              <a:rPr lang="en-US"/>
               <a:t>Fifth level</a:t>
             </a:r>
-            <a:endParaRPr lang="en-US"/>
           </a:p>
         </p:txBody>
       </p:sp>
@@ -2731,7 +3163,7 @@
           <a:p>
             <a:fld id="{5BCAD085-E8A6-8845-BD4E-CB4CCA059FC4}" type="datetimeFigureOut">
               <a:rPr lang="en-US" smtClean="0"/>
-              <a:t>1/27/13</a:t>
+              <a:t>8/24/2026</a:t>
             </a:fld>
             <a:endParaRPr lang="en-US"/>
           </a:p>
@@ -3090,7 +3522,7 @@
 </file>
 
 <file path=ppt/slides/slide1.xml><?xml version="1.0" encoding="utf-8"?>
-<p:sld xmlns:a="http://schemas.openxmlformats.org/drawingml/2006/main" xmlns:p="http://schemas.openxmlformats.org/presentationml/2006/main" xmlns:r="http://schemas.openxmlformats.org/officeDocument/2006/relationships">
+<p:sld xmlns:a="http://schemas.openxmlformats.org/drawingml/2006/main" xmlns:r="http://schemas.openxmlformats.org/officeDocument/2006/relationships" xmlns:p="http://schemas.openxmlformats.org/presentationml/2006/main">
   <p:cSld>
     <p:bg>
       <p:bgPr>
@@ -3106,7 +3538,14 @@
         <p:cNvGrpSpPr/>
         <p:nvPr/>
       </p:nvGrpSpPr>
-      <p:grpSpPr/>
+      <p:grpSpPr>
+        <a:xfrm>
+          <a:off x="0" y="0"/>
+          <a:ext cx="0" cy="0"/>
+          <a:chOff x="0" y="0"/>
+          <a:chExt cx="0" cy="0"/>
+        </a:xfrm>
+      </p:grpSpPr>
       <p:sp>
         <p:nvSpPr>
           <p:cNvPr id="2" name="Rounded Rectangle 1"/>
@@ -3145,24 +3584,40 @@
           </a:fontRef>
         </p:style>
         <p:txBody>
-          <a:bodyPr rtlCol="0" anchor="ctr" wrap="square"/>
+          <a:bodyPr wrap="square" rtlCol="0" anchor="ctr"/>
           <a:lstStyle/>
           <a:p>
             <a:pPr algn="ctr"/>
             <a:r>
-              <a:rPr sz="3600" b="1">
+              <a:rPr sz="3600" b="1" dirty="0">
                 <a:solidFill>
                   <a:srgbClr val="0070F3"/>
                 </a:solidFill>
               </a:rPr>
-              <a:t>K.A.R.M.A CLOUD SIEM
+              <a:t> </a:t>
+            </a:r>
+            <a:r>
+              <a:rPr lang="en-US" sz="3600" b="1" dirty="0">
+                <a:solidFill>
+                  <a:srgbClr val="0070F3"/>
+                </a:solidFill>
+              </a:rPr>
+              <a:t>              </a:t>
+            </a:r>
+            <a:r>
+              <a:rPr sz="3600" b="1" dirty="0">
+                <a:solidFill>
+                  <a:srgbClr val="0070F3"/>
+                </a:solidFill>
+              </a:rPr>
+              <a:t>CLOUD SIEM
 </a:t>
             </a:r>
           </a:p>
           <a:p>
             <a:pPr algn="ctr"/>
             <a:r>
-              <a:rPr sz="1800">
+              <a:rPr sz="1800" dirty="0">
                 <a:solidFill>
                   <a:srgbClr val="F8FAFC"/>
                 </a:solidFill>
@@ -3174,7 +3629,7 @@
           <a:p>
             <a:pPr algn="ctr"/>
             <a:r>
-              <a:rPr sz="1300">
+              <a:rPr sz="1300" dirty="0">
                 <a:solidFill>
                   <a:srgbClr val="94A3B8"/>
                 </a:solidFill>
@@ -3185,12 +3640,58 @@
 Development Team:
 Abhijeet Kumar (Team Lead &amp; Core Architect)
 Kanaka C (Security Analyst &amp; Frontend Engineer)
-Raghunandan T V (Backend Engineer &amp; Threat Intelligence)
 </a:t>
             </a:r>
-          </a:p>
-        </p:txBody>
-      </p:sp>
+            <a:r>
+              <a:rPr sz="1300" dirty="0" err="1">
+                <a:solidFill>
+                  <a:srgbClr val="94A3B8"/>
+                </a:solidFill>
+              </a:rPr>
+              <a:t>Raghunandan</a:t>
+            </a:r>
+            <a:r>
+              <a:rPr sz="1300" dirty="0">
+                <a:solidFill>
+                  <a:srgbClr val="94A3B8"/>
+                </a:solidFill>
+              </a:rPr>
+              <a:t> T V (Backend Engineer &amp; Threat Intelligence)
+</a:t>
+            </a:r>
+          </a:p>
+        </p:txBody>
+      </p:sp>
+      <p:pic>
+        <p:nvPicPr>
+          <p:cNvPr id="4" name="Picture 3">
+            <a:extLst>
+              <a:ext uri="{FF2B5EF4-FFF2-40B4-BE49-F238E27FC236}">
+                <a16:creationId xmlns:a16="http://schemas.microsoft.com/office/drawing/2014/main" id="{7C19BD78-64D6-4D15-822F-D71E5C608664}"/>
+              </a:ext>
+            </a:extLst>
+          </p:cNvPr>
+          <p:cNvPicPr>
+            <a:picLocks noChangeAspect="1"/>
+          </p:cNvPicPr>
+          <p:nvPr/>
+        </p:nvPicPr>
+        <p:blipFill>
+          <a:blip r:embed="rId2"/>
+          <a:stretch>
+            <a:fillRect/>
+          </a:stretch>
+        </p:blipFill>
+        <p:spPr>
+          <a:xfrm>
+            <a:off x="3410712" y="1434938"/>
+            <a:ext cx="2128266" cy="687691"/>
+          </a:xfrm>
+          <a:prstGeom prst="rect">
+            <a:avLst/>
+          </a:prstGeom>
+        </p:spPr>
+      </p:pic>
     </p:spTree>
   </p:cSld>
   <p:clrMapOvr>
@@ -3200,7 +3701,7 @@
 </file>
 
 <file path=ppt/slides/slide10.xml><?xml version="1.0" encoding="utf-8"?>
-<p:sld xmlns:a="http://schemas.openxmlformats.org/drawingml/2006/main" xmlns:p="http://schemas.openxmlformats.org/presentationml/2006/main" xmlns:r="http://schemas.openxmlformats.org/officeDocument/2006/relationships">
+<p:sld xmlns:a="http://schemas.openxmlformats.org/drawingml/2006/main" xmlns:r="http://schemas.openxmlformats.org/officeDocument/2006/relationships" xmlns:p="http://schemas.openxmlformats.org/presentationml/2006/main">
   <p:cSld>
     <p:bg>
       <p:bgPr>
@@ -3216,40 +3717,14 @@
         <p:cNvGrpSpPr/>
         <p:nvPr/>
       </p:nvGrpSpPr>
-      <p:grpSpPr/>
-      <p:sp>
-        <p:nvSpPr>
-          <p:cNvPr id="2" name="TextBox 1"/>
-          <p:cNvSpPr txBox="1"/>
-          <p:nvPr/>
-        </p:nvSpPr>
-        <p:spPr>
-          <a:xfrm>
-            <a:off x="548640" y="228600"/>
-            <a:ext cx="10972800" cy="320040"/>
-          </a:xfrm>
-          <a:prstGeom prst="rect">
-            <a:avLst/>
-          </a:prstGeom>
-          <a:noFill/>
-        </p:spPr>
-        <p:txBody>
-          <a:bodyPr wrap="none">
-            <a:spAutoFit/>
-          </a:bodyPr>
-          <a:lstStyle/>
-          <a:p>
-            <a:r>
-              <a:rPr sz="1000" b="1">
-                <a:solidFill>
-                  <a:srgbClr val="10B981"/>
-                </a:solidFill>
-              </a:rPr>
-              <a:t>K.A.R.M.A CLOUD SIEM</a:t>
-            </a:r>
-          </a:p>
-        </p:txBody>
-      </p:sp>
+      <p:grpSpPr>
+        <a:xfrm>
+          <a:off x="0" y="0"/>
+          <a:ext cx="0" cy="0"/>
+          <a:chOff x="0" y="0"/>
+          <a:chExt cx="0" cy="0"/>
+        </a:xfrm>
+      </p:grpSpPr>
       <p:sp>
         <p:nvSpPr>
           <p:cNvPr id="3" name="TextBox 2"/>
@@ -3315,8 +3790,8 @@
         </p:nvSpPr>
         <p:spPr>
           <a:xfrm>
-            <a:off x="731520" y="1188720"/>
-            <a:ext cx="3474720" cy="1143000"/>
+            <a:off x="2089481" y="5989320"/>
+            <a:ext cx="2787015" cy="731520"/>
           </a:xfrm>
           <a:prstGeom prst="roundRect">
             <a:avLst/>
@@ -3345,12 +3820,12 @@
           </a:fontRef>
         </p:style>
         <p:txBody>
-          <a:bodyPr rtlCol="0" anchor="ctr" wrap="square"/>
+          <a:bodyPr wrap="square" rtlCol="0" anchor="ctr"/>
           <a:lstStyle/>
           <a:p>
             <a:pPr algn="ctr"/>
             <a:r>
-              <a:rPr sz="1100" b="1">
+              <a:rPr sz="1100" b="1" dirty="0">
                 <a:solidFill>
                   <a:srgbClr val="0070F3"/>
                 </a:solidFill>
@@ -3360,13 +3835,30 @@
             </a:r>
           </a:p>
           <a:p>
-            <a:r>
-              <a:rPr sz="950">
+            <a:pPr algn="ctr"/>
+            <a:r>
+              <a:rPr sz="950" dirty="0">
                 <a:solidFill>
                   <a:srgbClr val="94A3B8"/>
                 </a:solidFill>
               </a:rPr>
-              <a:t>Uploads raw .eml / .msg RFC822 MIME email files for deep structure inspection.</a:t>
+              <a:t>Uploads raw .</a:t>
+            </a:r>
+            <a:r>
+              <a:rPr sz="950" dirty="0" err="1">
+                <a:solidFill>
+                  <a:srgbClr val="94A3B8"/>
+                </a:solidFill>
+              </a:rPr>
+              <a:t>eml</a:t>
+            </a:r>
+            <a:r>
+              <a:rPr sz="950" dirty="0">
+                <a:solidFill>
+                  <a:srgbClr val="94A3B8"/>
+                </a:solidFill>
+              </a:rPr>
+              <a:t> / .msg RFC822 MIME email files for deep structure inspection.</a:t>
             </a:r>
           </a:p>
         </p:txBody>
@@ -3379,8 +3871,8 @@
         </p:nvSpPr>
         <p:spPr>
           <a:xfrm>
-            <a:off x="7955279" y="1188720"/>
-            <a:ext cx="3474720" cy="1143000"/>
+            <a:off x="8680781" y="5989320"/>
+            <a:ext cx="2962274" cy="731519"/>
           </a:xfrm>
           <a:prstGeom prst="roundRect">
             <a:avLst/>
@@ -3409,12 +3901,12 @@
           </a:fontRef>
         </p:style>
         <p:txBody>
-          <a:bodyPr rtlCol="0" anchor="ctr" wrap="square"/>
+          <a:bodyPr wrap="square" rtlCol="0" anchor="ctr"/>
           <a:lstStyle/>
           <a:p>
             <a:pPr algn="ctr"/>
             <a:r>
-              <a:rPr sz="1100" b="1">
+              <a:rPr sz="1100" b="1" dirty="0">
                 <a:solidFill>
                   <a:srgbClr val="8B5CF6"/>
                 </a:solidFill>
@@ -3424,8 +3916,9 @@
             </a:r>
           </a:p>
           <a:p>
-            <a:r>
-              <a:rPr sz="950">
+            <a:pPr algn="ctr"/>
+            <a:r>
+              <a:rPr sz="950" dirty="0">
                 <a:solidFill>
                   <a:srgbClr val="94A3B8"/>
                 </a:solidFill>
@@ -3443,8 +3936,8 @@
         </p:nvSpPr>
         <p:spPr>
           <a:xfrm>
-            <a:off x="4206240" y="5120640"/>
-            <a:ext cx="3840480" cy="1143000"/>
+            <a:off x="5122241" y="5989320"/>
+            <a:ext cx="3312795" cy="731520"/>
           </a:xfrm>
           <a:prstGeom prst="roundRect">
             <a:avLst/>
@@ -3473,23 +3966,40 @@
           </a:fontRef>
         </p:style>
         <p:txBody>
-          <a:bodyPr rtlCol="0" anchor="ctr" wrap="square"/>
+          <a:bodyPr wrap="square" rtlCol="0" anchor="ctr"/>
           <a:lstStyle/>
           <a:p>
             <a:pPr algn="ctr"/>
             <a:r>
-              <a:rPr sz="1100" b="1">
+              <a:rPr sz="1100" b="1" dirty="0">
                 <a:solidFill>
                   <a:srgbClr val="10B981"/>
                 </a:solidFill>
               </a:rPr>
-              <a:t>🤖 DeepSeek AI Threat Assessment
+              <a:t>🤖 </a:t>
+            </a:r>
+            <a:r>
+              <a:rPr sz="1100" b="1" dirty="0" err="1">
+                <a:solidFill>
+                  <a:srgbClr val="10B981"/>
+                </a:solidFill>
+              </a:rPr>
+              <a:t>DeepSeek</a:t>
+            </a:r>
+            <a:r>
+              <a:rPr sz="1100" b="1" dirty="0">
+                <a:solidFill>
+                  <a:srgbClr val="10B981"/>
+                </a:solidFill>
+              </a:rPr>
+              <a:t> AI Threat Assessment
 </a:t>
             </a:r>
           </a:p>
           <a:p>
-            <a:r>
-              <a:rPr sz="950">
+            <a:pPr algn="ctr"/>
+            <a:r>
+              <a:rPr sz="950" dirty="0">
                 <a:solidFill>
                   <a:srgbClr val="94A3B8"/>
                 </a:solidFill>
@@ -3499,6 +4009,36 @@
           </a:p>
         </p:txBody>
       </p:sp>
+      <p:pic>
+        <p:nvPicPr>
+          <p:cNvPr id="8" name="Picture 7">
+            <a:extLst>
+              <a:ext uri="{FF2B5EF4-FFF2-40B4-BE49-F238E27FC236}">
+                <a16:creationId xmlns:a16="http://schemas.microsoft.com/office/drawing/2014/main" id="{BCA9AFC4-BF19-EA22-59B7-AFB6BDD7193C}"/>
+              </a:ext>
+            </a:extLst>
+          </p:cNvPr>
+          <p:cNvPicPr>
+            <a:picLocks noChangeAspect="1"/>
+          </p:cNvPicPr>
+          <p:nvPr/>
+        </p:nvPicPr>
+        <p:blipFill>
+          <a:blip r:embed="rId3"/>
+          <a:stretch>
+            <a:fillRect/>
+          </a:stretch>
+        </p:blipFill>
+        <p:spPr>
+          <a:xfrm>
+            <a:off x="118872" y="48690"/>
+            <a:ext cx="1570482" cy="507458"/>
+          </a:xfrm>
+          <a:prstGeom prst="rect">
+            <a:avLst/>
+          </a:prstGeom>
+        </p:spPr>
+      </p:pic>
     </p:spTree>
   </p:cSld>
   <p:clrMapOvr>
@@ -3508,7 +4048,7 @@
 </file>
 
 <file path=ppt/slides/slide11.xml><?xml version="1.0" encoding="utf-8"?>
-<p:sld xmlns:a="http://schemas.openxmlformats.org/drawingml/2006/main" xmlns:p="http://schemas.openxmlformats.org/presentationml/2006/main" xmlns:r="http://schemas.openxmlformats.org/officeDocument/2006/relationships">
+<p:sld xmlns:a="http://schemas.openxmlformats.org/drawingml/2006/main" xmlns:r="http://schemas.openxmlformats.org/officeDocument/2006/relationships" xmlns:p="http://schemas.openxmlformats.org/presentationml/2006/main">
   <p:cSld>
     <p:bg>
       <p:bgPr>
@@ -3524,40 +4064,14 @@
         <p:cNvGrpSpPr/>
         <p:nvPr/>
       </p:nvGrpSpPr>
-      <p:grpSpPr/>
-      <p:sp>
-        <p:nvSpPr>
-          <p:cNvPr id="2" name="TextBox 1"/>
-          <p:cNvSpPr txBox="1"/>
-          <p:nvPr/>
-        </p:nvSpPr>
-        <p:spPr>
-          <a:xfrm>
-            <a:off x="548640" y="228600"/>
-            <a:ext cx="10972800" cy="320040"/>
-          </a:xfrm>
-          <a:prstGeom prst="rect">
-            <a:avLst/>
-          </a:prstGeom>
-          <a:noFill/>
-        </p:spPr>
-        <p:txBody>
-          <a:bodyPr wrap="none">
-            <a:spAutoFit/>
-          </a:bodyPr>
-          <a:lstStyle/>
-          <a:p>
-            <a:r>
-              <a:rPr sz="1000" b="1">
-                <a:solidFill>
-                  <a:srgbClr val="10B981"/>
-                </a:solidFill>
-              </a:rPr>
-              <a:t>K.A.R.M.A CLOUD SIEM</a:t>
-            </a:r>
-          </a:p>
-        </p:txBody>
-      </p:sp>
+      <p:grpSpPr>
+        <a:xfrm>
+          <a:off x="0" y="0"/>
+          <a:ext cx="0" cy="0"/>
+          <a:chOff x="0" y="0"/>
+          <a:chExt cx="0" cy="0"/>
+        </a:xfrm>
+      </p:grpSpPr>
       <p:sp>
         <p:nvSpPr>
           <p:cNvPr id="3" name="TextBox 2"/>
@@ -3623,8 +4137,8 @@
         </p:nvSpPr>
         <p:spPr>
           <a:xfrm>
-            <a:off x="731520" y="1188720"/>
-            <a:ext cx="3474720" cy="1143000"/>
+            <a:off x="2114549" y="5979794"/>
+            <a:ext cx="2767965" cy="750570"/>
           </a:xfrm>
           <a:prstGeom prst="roundRect">
             <a:avLst/>
@@ -3653,12 +4167,12 @@
           </a:fontRef>
         </p:style>
         <p:txBody>
-          <a:bodyPr rtlCol="0" anchor="ctr" wrap="square"/>
+          <a:bodyPr wrap="square" rtlCol="0" anchor="ctr"/>
           <a:lstStyle/>
           <a:p>
             <a:pPr algn="ctr"/>
             <a:r>
-              <a:rPr sz="1100" b="1">
+              <a:rPr sz="1100" b="1" dirty="0">
                 <a:solidFill>
                   <a:srgbClr val="0070F3"/>
                 </a:solidFill>
@@ -3668,8 +4182,9 @@
             </a:r>
           </a:p>
           <a:p>
-            <a:r>
-              <a:rPr sz="950">
+            <a:pPr algn="ctr"/>
+            <a:r>
+              <a:rPr sz="950" dirty="0">
                 <a:solidFill>
                   <a:srgbClr val="94A3B8"/>
                 </a:solidFill>
@@ -3687,8 +4202,8 @@
         </p:nvSpPr>
         <p:spPr>
           <a:xfrm>
-            <a:off x="7955279" y="1188720"/>
-            <a:ext cx="3474720" cy="1143000"/>
+            <a:off x="5048250" y="5979794"/>
+            <a:ext cx="4200524" cy="750571"/>
           </a:xfrm>
           <a:prstGeom prst="roundRect">
             <a:avLst/>
@@ -3717,12 +4232,12 @@
           </a:fontRef>
         </p:style>
         <p:txBody>
-          <a:bodyPr rtlCol="0" anchor="ctr" wrap="square"/>
+          <a:bodyPr wrap="square" rtlCol="0" anchor="ctr"/>
           <a:lstStyle/>
           <a:p>
             <a:pPr algn="ctr"/>
             <a:r>
-              <a:rPr sz="1100" b="1">
+              <a:rPr sz="1100" b="1" dirty="0">
                 <a:solidFill>
                   <a:srgbClr val="10B981"/>
                 </a:solidFill>
@@ -3732,81 +4247,64 @@
             </a:r>
           </a:p>
           <a:p>
-            <a:r>
-              <a:rPr sz="950">
+            <a:pPr algn="ctr"/>
+            <a:r>
+              <a:rPr sz="950" dirty="0">
                 <a:solidFill>
                   <a:srgbClr val="94A3B8"/>
                 </a:solidFill>
               </a:rPr>
-              <a:t>Guide: Mr. Subhash J R | Team: Abhijeet Kumar, Kanaka C, Raghunandan T V.</a:t>
-            </a:r>
-          </a:p>
-        </p:txBody>
-      </p:sp>
-      <p:sp>
-        <p:nvSpPr>
-          <p:cNvPr id="7" name="Rounded Rectangle 6"/>
-          <p:cNvSpPr/>
+              <a:t>Guide: Mr. Subhash J R | Team: Abhijeet Kumar, Kanaka C, </a:t>
+            </a:r>
+            <a:r>
+              <a:rPr sz="950" dirty="0" err="1">
+                <a:solidFill>
+                  <a:srgbClr val="94A3B8"/>
+                </a:solidFill>
+              </a:rPr>
+              <a:t>Raghunandan</a:t>
+            </a:r>
+            <a:r>
+              <a:rPr sz="950" dirty="0">
+                <a:solidFill>
+                  <a:srgbClr val="94A3B8"/>
+                </a:solidFill>
+              </a:rPr>
+              <a:t> T V.</a:t>
+            </a:r>
+          </a:p>
+        </p:txBody>
+      </p:sp>
+      <p:pic>
+        <p:nvPicPr>
+          <p:cNvPr id="8" name="Picture 7">
+            <a:extLst>
+              <a:ext uri="{FF2B5EF4-FFF2-40B4-BE49-F238E27FC236}">
+                <a16:creationId xmlns:a16="http://schemas.microsoft.com/office/drawing/2014/main" id="{56AD9E4E-3552-D851-A5E5-5811B4A5C2B6}"/>
+              </a:ext>
+            </a:extLst>
+          </p:cNvPr>
+          <p:cNvPicPr>
+            <a:picLocks noChangeAspect="1"/>
+          </p:cNvPicPr>
           <p:nvPr/>
-        </p:nvSpPr>
-        <p:spPr>
-          <a:xfrm>
-            <a:off x="4206240" y="5120640"/>
-            <a:ext cx="3840480" cy="1143000"/>
-          </a:xfrm>
-          <a:prstGeom prst="roundRect">
+        </p:nvPicPr>
+        <p:blipFill>
+          <a:blip r:embed="rId3"/>
+          <a:stretch>
+            <a:fillRect/>
+          </a:stretch>
+        </p:blipFill>
+        <p:spPr>
+          <a:xfrm>
+            <a:off x="118872" y="48690"/>
+            <a:ext cx="1570482" cy="507458"/>
+          </a:xfrm>
+          <a:prstGeom prst="rect">
             <a:avLst/>
           </a:prstGeom>
-          <a:solidFill>
-            <a:srgbClr val="0F172A"/>
-          </a:solidFill>
-          <a:ln w="25400">
-            <a:solidFill>
-              <a:srgbClr val="8B5CF6"/>
-            </a:solidFill>
-          </a:ln>
-        </p:spPr>
-        <p:style>
-          <a:lnRef idx="1">
-            <a:schemeClr val="accent1"/>
-          </a:lnRef>
-          <a:fillRef idx="3">
-            <a:schemeClr val="accent1"/>
-          </a:fillRef>
-          <a:effectRef idx="2">
-            <a:schemeClr val="accent1"/>
-          </a:effectRef>
-          <a:fontRef idx="minor">
-            <a:schemeClr val="lt1"/>
-          </a:fontRef>
-        </p:style>
-        <p:txBody>
-          <a:bodyPr rtlCol="0" anchor="ctr" wrap="square"/>
-          <a:lstStyle/>
-          <a:p>
-            <a:pPr algn="ctr"/>
-            <a:r>
-              <a:rPr sz="1100" b="1">
-                <a:solidFill>
-                  <a:srgbClr val="8B5CF6"/>
-                </a:solidFill>
-              </a:rPr>
-              <a:t>📦 Standalone App Package (setup.py)
-</a:t>
-            </a:r>
-          </a:p>
-          <a:p>
-            <a:r>
-              <a:rPr sz="950">
-                <a:solidFill>
-                  <a:srgbClr val="94A3B8"/>
-                </a:solidFill>
-              </a:rPr>
-              <a:t>Compiles into KARMA_Cloud_SIEM_Standalone_v1.0.zip (53 MB) to run on any PC without Python/pip.</a:t>
-            </a:r>
-          </a:p>
-        </p:txBody>
-      </p:sp>
+        </p:spPr>
+      </p:pic>
     </p:spTree>
   </p:cSld>
   <p:clrMapOvr>
@@ -3816,7 +4314,7 @@
 </file>
 
 <file path=ppt/slides/slide12.xml><?xml version="1.0" encoding="utf-8"?>
-<p:sld xmlns:a="http://schemas.openxmlformats.org/drawingml/2006/main" xmlns:p="http://schemas.openxmlformats.org/presentationml/2006/main" xmlns:r="http://schemas.openxmlformats.org/officeDocument/2006/relationships">
+<p:sld xmlns:a="http://schemas.openxmlformats.org/drawingml/2006/main" xmlns:r="http://schemas.openxmlformats.org/officeDocument/2006/relationships" xmlns:p="http://schemas.openxmlformats.org/presentationml/2006/main">
   <p:cSld>
     <p:bg>
       <p:bgPr>
@@ -3832,7 +4330,14 @@
         <p:cNvGrpSpPr/>
         <p:nvPr/>
       </p:nvGrpSpPr>
-      <p:grpSpPr/>
+      <p:grpSpPr>
+        <a:xfrm>
+          <a:off x="0" y="0"/>
+          <a:ext cx="0" cy="0"/>
+          <a:chOff x="0" y="0"/>
+          <a:chExt cx="0" cy="0"/>
+        </a:xfrm>
+      </p:grpSpPr>
       <p:sp>
         <p:nvSpPr>
           <p:cNvPr id="2" name="Rounded Rectangle 1"/>
@@ -3871,12 +4376,12 @@
           </a:fontRef>
         </p:style>
         <p:txBody>
-          <a:bodyPr rtlCol="0" anchor="ctr" wrap="square"/>
+          <a:bodyPr wrap="square" rtlCol="0" anchor="ctr"/>
           <a:lstStyle/>
           <a:p>
             <a:pPr algn="ctr"/>
             <a:r>
-              <a:rPr sz="3600" b="1">
+              <a:rPr sz="3600" b="1" dirty="0">
                 <a:solidFill>
                   <a:srgbClr val="10B981"/>
                 </a:solidFill>
@@ -3888,7 +4393,7 @@
           <a:p>
             <a:pPr algn="ctr"/>
             <a:r>
-              <a:rPr sz="1600">
+              <a:rPr sz="1600" dirty="0">
                 <a:solidFill>
                   <a:srgbClr val="F8FAFC"/>
                 </a:solidFill>
@@ -3900,18 +4405,47 @@
           <a:p>
             <a:pPr algn="ctr"/>
             <a:r>
-              <a:rPr sz="1400">
+              <a:rPr sz="1400" dirty="0">
                 <a:solidFill>
                   <a:srgbClr val="94A3B8"/>
                 </a:solidFill>
               </a:rPr>
               <a:t>Department of Computer Science &amp; Engineering • Major Project (20CS61P)
-The Oxford Evening Polytechnic, Bangalore
-Questions &amp; Answers Session</a:t>
-            </a:r>
-          </a:p>
-        </p:txBody>
-      </p:sp>
+The Oxford Evening Polytechnic, Bangalore</a:t>
+            </a:r>
+          </a:p>
+        </p:txBody>
+      </p:sp>
+      <p:pic>
+        <p:nvPicPr>
+          <p:cNvPr id="3" name="Picture 2">
+            <a:extLst>
+              <a:ext uri="{FF2B5EF4-FFF2-40B4-BE49-F238E27FC236}">
+                <a16:creationId xmlns:a16="http://schemas.microsoft.com/office/drawing/2014/main" id="{D919FDF4-7823-3194-9ADA-C2BFCD54813B}"/>
+              </a:ext>
+            </a:extLst>
+          </p:cNvPr>
+          <p:cNvPicPr>
+            <a:picLocks noChangeAspect="1"/>
+          </p:cNvPicPr>
+          <p:nvPr/>
+        </p:nvPicPr>
+        <p:blipFill>
+          <a:blip r:embed="rId2"/>
+          <a:stretch>
+            <a:fillRect/>
+          </a:stretch>
+        </p:blipFill>
+        <p:spPr>
+          <a:xfrm>
+            <a:off x="118872" y="48690"/>
+            <a:ext cx="1570482" cy="507458"/>
+          </a:xfrm>
+          <a:prstGeom prst="rect">
+            <a:avLst/>
+          </a:prstGeom>
+        </p:spPr>
+      </p:pic>
     </p:spTree>
   </p:cSld>
   <p:clrMapOvr>
@@ -3921,7 +4455,7 @@
 </file>
 
 <file path=ppt/slides/slide2.xml><?xml version="1.0" encoding="utf-8"?>
-<p:sld xmlns:a="http://schemas.openxmlformats.org/drawingml/2006/main" xmlns:p="http://schemas.openxmlformats.org/presentationml/2006/main" xmlns:r="http://schemas.openxmlformats.org/officeDocument/2006/relationships">
+<p:sld xmlns:a="http://schemas.openxmlformats.org/drawingml/2006/main" xmlns:r="http://schemas.openxmlformats.org/officeDocument/2006/relationships" xmlns:p="http://schemas.openxmlformats.org/presentationml/2006/main">
   <p:cSld>
     <p:bg>
       <p:bgPr>
@@ -3937,40 +4471,14 @@
         <p:cNvGrpSpPr/>
         <p:nvPr/>
       </p:nvGrpSpPr>
-      <p:grpSpPr/>
-      <p:sp>
-        <p:nvSpPr>
-          <p:cNvPr id="2" name="TextBox 1"/>
-          <p:cNvSpPr txBox="1"/>
-          <p:nvPr/>
-        </p:nvSpPr>
-        <p:spPr>
-          <a:xfrm>
-            <a:off x="548640" y="228600"/>
-            <a:ext cx="10972800" cy="320040"/>
-          </a:xfrm>
-          <a:prstGeom prst="rect">
-            <a:avLst/>
-          </a:prstGeom>
-          <a:noFill/>
-        </p:spPr>
-        <p:txBody>
-          <a:bodyPr wrap="none">
-            <a:spAutoFit/>
-          </a:bodyPr>
-          <a:lstStyle/>
-          <a:p>
-            <a:r>
-              <a:rPr sz="1000" b="1">
-                <a:solidFill>
-                  <a:srgbClr val="10B981"/>
-                </a:solidFill>
-              </a:rPr>
-              <a:t>K.A.R.M.A CLOUD SIEM</a:t>
-            </a:r>
-          </a:p>
-        </p:txBody>
-      </p:sp>
+      <p:grpSpPr>
+        <a:xfrm>
+          <a:off x="0" y="0"/>
+          <a:ext cx="0" cy="0"/>
+          <a:chOff x="0" y="0"/>
+          <a:chExt cx="0" cy="0"/>
+        </a:xfrm>
+      </p:grpSpPr>
       <p:sp>
         <p:nvSpPr>
           <p:cNvPr id="3" name="TextBox 2"/>
@@ -4032,7 +4540,7 @@
               </a:spcAft>
             </a:pPr>
             <a:r>
-              <a:rPr b="1" sz="1300">
+              <a:rPr sz="1300" b="1">
                 <a:solidFill>
                   <a:srgbClr val="0070F3"/>
                 </a:solidFill>
@@ -4055,7 +4563,7 @@
               </a:spcAft>
             </a:pPr>
             <a:r>
-              <a:rPr b="1" sz="1300">
+              <a:rPr sz="1300" b="1">
                 <a:solidFill>
                   <a:srgbClr val="0070F3"/>
                 </a:solidFill>
@@ -4078,7 +4586,7 @@
               </a:spcAft>
             </a:pPr>
             <a:r>
-              <a:rPr b="1" sz="1300">
+              <a:rPr sz="1300" b="1">
                 <a:solidFill>
                   <a:srgbClr val="0070F3"/>
                 </a:solidFill>
@@ -4101,7 +4609,7 @@
               </a:spcAft>
             </a:pPr>
             <a:r>
-              <a:rPr b="1" sz="1300">
+              <a:rPr sz="1300" b="1">
                 <a:solidFill>
                   <a:srgbClr val="0070F3"/>
                 </a:solidFill>
@@ -4124,7 +4632,7 @@
               </a:spcAft>
             </a:pPr>
             <a:r>
-              <a:rPr b="1" sz="1300">
+              <a:rPr sz="1300" b="1">
                 <a:solidFill>
                   <a:srgbClr val="0070F3"/>
                 </a:solidFill>
@@ -4142,6 +4650,36 @@
           </a:p>
         </p:txBody>
       </p:sp>
+      <p:pic>
+        <p:nvPicPr>
+          <p:cNvPr id="8" name="Picture 7">
+            <a:extLst>
+              <a:ext uri="{FF2B5EF4-FFF2-40B4-BE49-F238E27FC236}">
+                <a16:creationId xmlns:a16="http://schemas.microsoft.com/office/drawing/2014/main" id="{443F2FA7-0927-B2AF-7A86-409E622B01F4}"/>
+              </a:ext>
+            </a:extLst>
+          </p:cNvPr>
+          <p:cNvPicPr>
+            <a:picLocks noChangeAspect="1"/>
+          </p:cNvPicPr>
+          <p:nvPr/>
+        </p:nvPicPr>
+        <p:blipFill>
+          <a:blip r:embed="rId2"/>
+          <a:stretch>
+            <a:fillRect/>
+          </a:stretch>
+        </p:blipFill>
+        <p:spPr>
+          <a:xfrm>
+            <a:off x="118872" y="48690"/>
+            <a:ext cx="1570482" cy="507458"/>
+          </a:xfrm>
+          <a:prstGeom prst="rect">
+            <a:avLst/>
+          </a:prstGeom>
+        </p:spPr>
+      </p:pic>
     </p:spTree>
   </p:cSld>
   <p:clrMapOvr>
@@ -4151,7 +4689,7 @@
 </file>
 
 <file path=ppt/slides/slide3.xml><?xml version="1.0" encoding="utf-8"?>
-<p:sld xmlns:a="http://schemas.openxmlformats.org/drawingml/2006/main" xmlns:p="http://schemas.openxmlformats.org/presentationml/2006/main" xmlns:r="http://schemas.openxmlformats.org/officeDocument/2006/relationships">
+<p:sld xmlns:a="http://schemas.openxmlformats.org/drawingml/2006/main" xmlns:r="http://schemas.openxmlformats.org/officeDocument/2006/relationships" xmlns:p="http://schemas.openxmlformats.org/presentationml/2006/main">
   <p:cSld>
     <p:bg>
       <p:bgPr>
@@ -4167,40 +4705,14 @@
         <p:cNvGrpSpPr/>
         <p:nvPr/>
       </p:nvGrpSpPr>
-      <p:grpSpPr/>
-      <p:sp>
-        <p:nvSpPr>
-          <p:cNvPr id="2" name="TextBox 1"/>
-          <p:cNvSpPr txBox="1"/>
-          <p:nvPr/>
-        </p:nvSpPr>
-        <p:spPr>
-          <a:xfrm>
-            <a:off x="548640" y="228600"/>
-            <a:ext cx="10972800" cy="320040"/>
-          </a:xfrm>
-          <a:prstGeom prst="rect">
-            <a:avLst/>
-          </a:prstGeom>
-          <a:noFill/>
-        </p:spPr>
-        <p:txBody>
-          <a:bodyPr wrap="none">
-            <a:spAutoFit/>
-          </a:bodyPr>
-          <a:lstStyle/>
-          <a:p>
-            <a:r>
-              <a:rPr sz="1000" b="1">
-                <a:solidFill>
-                  <a:srgbClr val="10B981"/>
-                </a:solidFill>
-              </a:rPr>
-              <a:t>K.A.R.M.A CLOUD SIEM</a:t>
-            </a:r>
-          </a:p>
-        </p:txBody>
-      </p:sp>
+      <p:grpSpPr>
+        <a:xfrm>
+          <a:off x="0" y="0"/>
+          <a:ext cx="0" cy="0"/>
+          <a:chOff x="0" y="0"/>
+          <a:chExt cx="0" cy="0"/>
+        </a:xfrm>
+      </p:grpSpPr>
       <p:sp>
         <p:nvSpPr>
           <p:cNvPr id="3" name="TextBox 2"/>
@@ -4262,7 +4774,7 @@
               </a:spcAft>
             </a:pPr>
             <a:r>
-              <a:rPr b="1" sz="1300">
+              <a:rPr sz="1300" b="1">
                 <a:solidFill>
                   <a:srgbClr val="0070F3"/>
                 </a:solidFill>
@@ -4285,7 +4797,7 @@
               </a:spcAft>
             </a:pPr>
             <a:r>
-              <a:rPr b="1" sz="1300">
+              <a:rPr sz="1300" b="1">
                 <a:solidFill>
                   <a:srgbClr val="0070F3"/>
                 </a:solidFill>
@@ -4308,7 +4820,7 @@
               </a:spcAft>
             </a:pPr>
             <a:r>
-              <a:rPr b="1" sz="1300">
+              <a:rPr sz="1300" b="1">
                 <a:solidFill>
                   <a:srgbClr val="0070F3"/>
                 </a:solidFill>
@@ -4331,7 +4843,7 @@
               </a:spcAft>
             </a:pPr>
             <a:r>
-              <a:rPr b="1" sz="1300">
+              <a:rPr sz="1300" b="1">
                 <a:solidFill>
                   <a:srgbClr val="0070F3"/>
                 </a:solidFill>
@@ -4354,7 +4866,7 @@
               </a:spcAft>
             </a:pPr>
             <a:r>
-              <a:rPr b="1" sz="1300">
+              <a:rPr sz="1300" b="1">
                 <a:solidFill>
                   <a:srgbClr val="0070F3"/>
                 </a:solidFill>
@@ -4372,6 +4884,36 @@
           </a:p>
         </p:txBody>
       </p:sp>
+      <p:pic>
+        <p:nvPicPr>
+          <p:cNvPr id="6" name="Picture 5">
+            <a:extLst>
+              <a:ext uri="{FF2B5EF4-FFF2-40B4-BE49-F238E27FC236}">
+                <a16:creationId xmlns:a16="http://schemas.microsoft.com/office/drawing/2014/main" id="{B309D220-8AF0-A882-5946-9F5F8D94DD86}"/>
+              </a:ext>
+            </a:extLst>
+          </p:cNvPr>
+          <p:cNvPicPr>
+            <a:picLocks noChangeAspect="1"/>
+          </p:cNvPicPr>
+          <p:nvPr/>
+        </p:nvPicPr>
+        <p:blipFill>
+          <a:blip r:embed="rId2"/>
+          <a:stretch>
+            <a:fillRect/>
+          </a:stretch>
+        </p:blipFill>
+        <p:spPr>
+          <a:xfrm>
+            <a:off x="118872" y="48690"/>
+            <a:ext cx="1570482" cy="507458"/>
+          </a:xfrm>
+          <a:prstGeom prst="rect">
+            <a:avLst/>
+          </a:prstGeom>
+        </p:spPr>
+      </p:pic>
     </p:spTree>
   </p:cSld>
   <p:clrMapOvr>
@@ -4381,7 +4923,7 @@
 </file>
 
 <file path=ppt/slides/slide4.xml><?xml version="1.0" encoding="utf-8"?>
-<p:sld xmlns:a="http://schemas.openxmlformats.org/drawingml/2006/main" xmlns:p="http://schemas.openxmlformats.org/presentationml/2006/main" xmlns:r="http://schemas.openxmlformats.org/officeDocument/2006/relationships">
+<p:sld xmlns:a="http://schemas.openxmlformats.org/drawingml/2006/main" xmlns:r="http://schemas.openxmlformats.org/officeDocument/2006/relationships" xmlns:p="http://schemas.openxmlformats.org/presentationml/2006/main">
   <p:cSld>
     <p:bg>
       <p:bgPr>
@@ -4397,40 +4939,14 @@
         <p:cNvGrpSpPr/>
         <p:nvPr/>
       </p:nvGrpSpPr>
-      <p:grpSpPr/>
-      <p:sp>
-        <p:nvSpPr>
-          <p:cNvPr id="2" name="TextBox 1"/>
-          <p:cNvSpPr txBox="1"/>
-          <p:nvPr/>
-        </p:nvSpPr>
-        <p:spPr>
-          <a:xfrm>
-            <a:off x="548640" y="228600"/>
-            <a:ext cx="10972800" cy="320040"/>
-          </a:xfrm>
-          <a:prstGeom prst="rect">
-            <a:avLst/>
-          </a:prstGeom>
-          <a:noFill/>
-        </p:spPr>
-        <p:txBody>
-          <a:bodyPr wrap="none">
-            <a:spAutoFit/>
-          </a:bodyPr>
-          <a:lstStyle/>
-          <a:p>
-            <a:r>
-              <a:rPr sz="1000" b="1">
-                <a:solidFill>
-                  <a:srgbClr val="10B981"/>
-                </a:solidFill>
-              </a:rPr>
-              <a:t>K.A.R.M.A CLOUD SIEM</a:t>
-            </a:r>
-          </a:p>
-        </p:txBody>
-      </p:sp>
+      <p:grpSpPr>
+        <a:xfrm>
+          <a:off x="0" y="0"/>
+          <a:ext cx="0" cy="0"/>
+          <a:chOff x="0" y="0"/>
+          <a:chExt cx="0" cy="0"/>
+        </a:xfrm>
+      </p:grpSpPr>
       <p:sp>
         <p:nvSpPr>
           <p:cNvPr id="3" name="TextBox 2"/>
@@ -4496,8 +5012,8 @@
         </p:nvSpPr>
         <p:spPr>
           <a:xfrm>
-            <a:off x="731520" y="1188720"/>
-            <a:ext cx="3474720" cy="1143000"/>
+            <a:off x="7105522" y="5900166"/>
+            <a:ext cx="2871216" cy="957834"/>
           </a:xfrm>
           <a:prstGeom prst="roundRect">
             <a:avLst/>
@@ -4526,12 +5042,12 @@
           </a:fontRef>
         </p:style>
         <p:txBody>
-          <a:bodyPr rtlCol="0" anchor="ctr" wrap="square"/>
+          <a:bodyPr wrap="square" rtlCol="0" anchor="ctr"/>
           <a:lstStyle/>
           <a:p>
             <a:pPr algn="ctr"/>
             <a:r>
-              <a:rPr sz="1100" b="1">
+              <a:rPr sz="1050" b="1">
                 <a:solidFill>
                   <a:srgbClr val="0070F3"/>
                 </a:solidFill>
@@ -4541,8 +5057,9 @@
             </a:r>
           </a:p>
           <a:p>
-            <a:r>
-              <a:rPr sz="950">
+            <a:pPr algn="ctr"/>
+            <a:r>
+              <a:rPr sz="900">
                 <a:solidFill>
                   <a:srgbClr val="94A3B8"/>
                 </a:solidFill>
@@ -4560,8 +5077,8 @@
         </p:nvSpPr>
         <p:spPr>
           <a:xfrm>
-            <a:off x="7955279" y="1188720"/>
-            <a:ext cx="3474720" cy="1143000"/>
+            <a:off x="10033632" y="5900166"/>
+            <a:ext cx="2072643" cy="957834"/>
           </a:xfrm>
           <a:prstGeom prst="roundRect">
             <a:avLst/>
@@ -4590,12 +5107,12 @@
           </a:fontRef>
         </p:style>
         <p:txBody>
-          <a:bodyPr rtlCol="0" anchor="ctr" wrap="square"/>
+          <a:bodyPr wrap="square" rtlCol="0" anchor="ctr"/>
           <a:lstStyle/>
           <a:p>
             <a:pPr algn="ctr"/>
             <a:r>
-              <a:rPr sz="1100" b="1">
+              <a:rPr sz="1050" b="1" dirty="0">
                 <a:solidFill>
                   <a:srgbClr val="10B981"/>
                 </a:solidFill>
@@ -4605,8 +5122,9 @@
             </a:r>
           </a:p>
           <a:p>
-            <a:r>
-              <a:rPr sz="950">
+            <a:pPr algn="ctr"/>
+            <a:r>
+              <a:rPr sz="900" dirty="0">
                 <a:solidFill>
                   <a:srgbClr val="94A3B8"/>
                 </a:solidFill>
@@ -4624,8 +5142,8 @@
         </p:nvSpPr>
         <p:spPr>
           <a:xfrm>
-            <a:off x="731520" y="5120640"/>
-            <a:ext cx="3474720" cy="1143000"/>
+            <a:off x="1359027" y="5900166"/>
+            <a:ext cx="2688336" cy="914400"/>
           </a:xfrm>
           <a:prstGeom prst="roundRect">
             <a:avLst/>
@@ -4654,12 +5172,12 @@
           </a:fontRef>
         </p:style>
         <p:txBody>
-          <a:bodyPr rtlCol="0" anchor="ctr" wrap="square"/>
+          <a:bodyPr wrap="square" rtlCol="0" anchor="ctr"/>
           <a:lstStyle/>
           <a:p>
             <a:pPr algn="ctr"/>
             <a:r>
-              <a:rPr sz="1100" b="1">
+              <a:rPr sz="1050" b="1">
                 <a:solidFill>
                   <a:srgbClr val="8B5CF6"/>
                 </a:solidFill>
@@ -4669,8 +5187,9 @@
             </a:r>
           </a:p>
           <a:p>
-            <a:r>
-              <a:rPr sz="950">
+            <a:pPr algn="ctr"/>
+            <a:r>
+              <a:rPr sz="900">
                 <a:solidFill>
                   <a:srgbClr val="94A3B8"/>
                 </a:solidFill>
@@ -4688,8 +5207,8 @@
         </p:nvSpPr>
         <p:spPr>
           <a:xfrm>
-            <a:off x="7955279" y="5120640"/>
-            <a:ext cx="3474720" cy="1143000"/>
+            <a:off x="4104258" y="5900166"/>
+            <a:ext cx="2944369" cy="957834"/>
           </a:xfrm>
           <a:prstGeom prst="roundRect">
             <a:avLst/>
@@ -4718,12 +5237,12 @@
           </a:fontRef>
         </p:style>
         <p:txBody>
-          <a:bodyPr rtlCol="0" anchor="ctr" wrap="square"/>
+          <a:bodyPr wrap="square" rtlCol="0" anchor="ctr"/>
           <a:lstStyle/>
           <a:p>
             <a:pPr algn="ctr"/>
             <a:r>
-              <a:rPr sz="1100" b="1">
+              <a:rPr sz="1050" b="1">
                 <a:solidFill>
                   <a:srgbClr val="F59E0B"/>
                 </a:solidFill>
@@ -4733,8 +5252,9 @@
             </a:r>
           </a:p>
           <a:p>
-            <a:r>
-              <a:rPr sz="950">
+            <a:pPr algn="ctr"/>
+            <a:r>
+              <a:rPr sz="900">
                 <a:solidFill>
                   <a:srgbClr val="94A3B8"/>
                 </a:solidFill>
@@ -4744,6 +5264,36 @@
           </a:p>
         </p:txBody>
       </p:sp>
+      <p:pic>
+        <p:nvPicPr>
+          <p:cNvPr id="9" name="Picture 8">
+            <a:extLst>
+              <a:ext uri="{FF2B5EF4-FFF2-40B4-BE49-F238E27FC236}">
+                <a16:creationId xmlns:a16="http://schemas.microsoft.com/office/drawing/2014/main" id="{C227242F-2F35-49CD-A74C-4D3162EFCABB}"/>
+              </a:ext>
+            </a:extLst>
+          </p:cNvPr>
+          <p:cNvPicPr>
+            <a:picLocks noChangeAspect="1"/>
+          </p:cNvPicPr>
+          <p:nvPr/>
+        </p:nvPicPr>
+        <p:blipFill>
+          <a:blip r:embed="rId3"/>
+          <a:stretch>
+            <a:fillRect/>
+          </a:stretch>
+        </p:blipFill>
+        <p:spPr>
+          <a:xfrm>
+            <a:off x="118872" y="48690"/>
+            <a:ext cx="1570482" cy="507458"/>
+          </a:xfrm>
+          <a:prstGeom prst="rect">
+            <a:avLst/>
+          </a:prstGeom>
+        </p:spPr>
+      </p:pic>
     </p:spTree>
   </p:cSld>
   <p:clrMapOvr>
@@ -4753,7 +5303,7 @@
 </file>
 
 <file path=ppt/slides/slide5.xml><?xml version="1.0" encoding="utf-8"?>
-<p:sld xmlns:a="http://schemas.openxmlformats.org/drawingml/2006/main" xmlns:p="http://schemas.openxmlformats.org/presentationml/2006/main" xmlns:r="http://schemas.openxmlformats.org/officeDocument/2006/relationships">
+<p:sld xmlns:a="http://schemas.openxmlformats.org/drawingml/2006/main" xmlns:r="http://schemas.openxmlformats.org/officeDocument/2006/relationships" xmlns:p="http://schemas.openxmlformats.org/presentationml/2006/main">
   <p:cSld>
     <p:bg>
       <p:bgPr>
@@ -4769,40 +5319,14 @@
         <p:cNvGrpSpPr/>
         <p:nvPr/>
       </p:nvGrpSpPr>
-      <p:grpSpPr/>
-      <p:sp>
-        <p:nvSpPr>
-          <p:cNvPr id="2" name="TextBox 1"/>
-          <p:cNvSpPr txBox="1"/>
-          <p:nvPr/>
-        </p:nvSpPr>
-        <p:spPr>
-          <a:xfrm>
-            <a:off x="548640" y="228600"/>
-            <a:ext cx="10972800" cy="320040"/>
-          </a:xfrm>
-          <a:prstGeom prst="rect">
-            <a:avLst/>
-          </a:prstGeom>
-          <a:noFill/>
-        </p:spPr>
-        <p:txBody>
-          <a:bodyPr wrap="none">
-            <a:spAutoFit/>
-          </a:bodyPr>
-          <a:lstStyle/>
-          <a:p>
-            <a:r>
-              <a:rPr sz="1000" b="1">
-                <a:solidFill>
-                  <a:srgbClr val="10B981"/>
-                </a:solidFill>
-              </a:rPr>
-              <a:t>K.A.R.M.A CLOUD SIEM</a:t>
-            </a:r>
-          </a:p>
-        </p:txBody>
-      </p:sp>
+      <p:grpSpPr>
+        <a:xfrm>
+          <a:off x="0" y="0"/>
+          <a:ext cx="0" cy="0"/>
+          <a:chOff x="0" y="0"/>
+          <a:chExt cx="0" cy="0"/>
+        </a:xfrm>
+      </p:grpSpPr>
       <p:sp>
         <p:nvSpPr>
           <p:cNvPr id="3" name="TextBox 2"/>
@@ -4845,7 +5369,7 @@
           <p:nvPr/>
         </p:nvPicPr>
         <p:blipFill>
-          <a:blip r:embed="rId2"/>
+          <a:blip r:embed="rId3"/>
           <a:stretch>
             <a:fillRect/>
           </a:stretch>
@@ -4868,8 +5392,8 @@
         </p:nvSpPr>
         <p:spPr>
           <a:xfrm>
-            <a:off x="731520" y="1188720"/>
-            <a:ext cx="3474720" cy="1143000"/>
+            <a:off x="3368676" y="5955030"/>
+            <a:ext cx="2663190" cy="834390"/>
           </a:xfrm>
           <a:prstGeom prst="roundRect">
             <a:avLst/>
@@ -4898,12 +5422,12 @@
           </a:fontRef>
         </p:style>
         <p:txBody>
-          <a:bodyPr rtlCol="0" anchor="ctr" wrap="square"/>
+          <a:bodyPr wrap="square" rtlCol="0" anchor="ctr"/>
           <a:lstStyle/>
           <a:p>
             <a:pPr algn="ctr"/>
             <a:r>
-              <a:rPr sz="1100" b="1">
+              <a:rPr sz="1100" b="1" dirty="0">
                 <a:solidFill>
                   <a:srgbClr val="0070F3"/>
                 </a:solidFill>
@@ -4913,13 +5437,22 @@
             </a:r>
           </a:p>
           <a:p>
-            <a:r>
-              <a:rPr sz="950">
+            <a:pPr algn="ctr"/>
+            <a:r>
+              <a:rPr sz="950" dirty="0" err="1">
                 <a:solidFill>
                   <a:srgbClr val="94A3B8"/>
                 </a:solidFill>
               </a:rPr>
-              <a:t>Paramiko SSH server with persistent RSA keys; traps auth attempts and logs interactive bash commands.</a:t>
+              <a:t>Paramiko</a:t>
+            </a:r>
+            <a:r>
+              <a:rPr sz="950" dirty="0">
+                <a:solidFill>
+                  <a:srgbClr val="94A3B8"/>
+                </a:solidFill>
+              </a:rPr>
+              <a:t> SSH server with persistent RSA keys; traps auth attempts and logs interactive bash commands.</a:t>
             </a:r>
           </a:p>
         </p:txBody>
@@ -4932,8 +5465,8 @@
         </p:nvSpPr>
         <p:spPr>
           <a:xfrm>
-            <a:off x="7955279" y="1188720"/>
-            <a:ext cx="3474720" cy="1143000"/>
+            <a:off x="9136381" y="5955030"/>
+            <a:ext cx="2676524" cy="834390"/>
           </a:xfrm>
           <a:prstGeom prst="roundRect">
             <a:avLst/>
@@ -4962,12 +5495,12 @@
           </a:fontRef>
         </p:style>
         <p:txBody>
-          <a:bodyPr rtlCol="0" anchor="ctr" wrap="square"/>
+          <a:bodyPr wrap="square" rtlCol="0" anchor="ctr"/>
           <a:lstStyle/>
           <a:p>
             <a:pPr algn="ctr"/>
             <a:r>
-              <a:rPr sz="1100" b="1">
+              <a:rPr sz="1100" b="1" dirty="0">
                 <a:solidFill>
                   <a:srgbClr val="10B981"/>
                 </a:solidFill>
@@ -4977,8 +5510,9 @@
             </a:r>
           </a:p>
           <a:p>
-            <a:r>
-              <a:rPr sz="950">
+            <a:pPr algn="ctr"/>
+            <a:r>
+              <a:rPr sz="950" dirty="0">
                 <a:solidFill>
                   <a:srgbClr val="94A3B8"/>
                 </a:solidFill>
@@ -4996,8 +5530,8 @@
         </p:nvSpPr>
         <p:spPr>
           <a:xfrm>
-            <a:off x="731520" y="5120640"/>
-            <a:ext cx="3474720" cy="1143000"/>
+            <a:off x="548640" y="5955030"/>
+            <a:ext cx="2663190" cy="834390"/>
           </a:xfrm>
           <a:prstGeom prst="roundRect">
             <a:avLst/>
@@ -5026,7 +5560,7 @@
           </a:fontRef>
         </p:style>
         <p:txBody>
-          <a:bodyPr rtlCol="0" anchor="ctr" wrap="square"/>
+          <a:bodyPr wrap="square" rtlCol="0" anchor="ctr"/>
           <a:lstStyle/>
           <a:p>
             <a:pPr algn="ctr"/>
@@ -5041,6 +5575,7 @@
             </a:r>
           </a:p>
           <a:p>
+            <a:pPr algn="ctr"/>
             <a:r>
               <a:rPr sz="950">
                 <a:solidFill>
@@ -5060,8 +5595,8 @@
         </p:nvSpPr>
         <p:spPr>
           <a:xfrm>
-            <a:off x="7955279" y="5120640"/>
-            <a:ext cx="3474720" cy="1143000"/>
+            <a:off x="6188712" y="5955030"/>
+            <a:ext cx="2790824" cy="834390"/>
           </a:xfrm>
           <a:prstGeom prst="roundRect">
             <a:avLst/>
@@ -5090,12 +5625,12 @@
           </a:fontRef>
         </p:style>
         <p:txBody>
-          <a:bodyPr rtlCol="0" anchor="ctr" wrap="square"/>
+          <a:bodyPr wrap="square" rtlCol="0" anchor="ctr"/>
           <a:lstStyle/>
           <a:p>
             <a:pPr algn="ctr"/>
             <a:r>
-              <a:rPr sz="1100" b="1">
+              <a:rPr sz="1100" b="1" dirty="0">
                 <a:solidFill>
                   <a:srgbClr val="F59E0B"/>
                 </a:solidFill>
@@ -5105,17 +5640,80 @@
             </a:r>
           </a:p>
           <a:p>
-            <a:r>
-              <a:rPr sz="950">
+            <a:pPr algn="ctr"/>
+            <a:r>
+              <a:rPr sz="950" dirty="0">
                 <a:solidFill>
                   <a:srgbClr val="94A3B8"/>
                 </a:solidFill>
               </a:rPr>
-              <a:t>Captures executed bash commands (whoami, id, cat /etc/passwd) and maps to MITRE ATT&amp;CK T1059.</a:t>
-            </a:r>
-          </a:p>
-        </p:txBody>
-      </p:sp>
+              <a:t>Captures executed bash commands (</a:t>
+            </a:r>
+            <a:r>
+              <a:rPr sz="950" dirty="0" err="1">
+                <a:solidFill>
+                  <a:srgbClr val="94A3B8"/>
+                </a:solidFill>
+              </a:rPr>
+              <a:t>whoami</a:t>
+            </a:r>
+            <a:r>
+              <a:rPr sz="950" dirty="0">
+                <a:solidFill>
+                  <a:srgbClr val="94A3B8"/>
+                </a:solidFill>
+              </a:rPr>
+              <a:t>, id, cat /</a:t>
+            </a:r>
+            <a:r>
+              <a:rPr sz="950" dirty="0" err="1">
+                <a:solidFill>
+                  <a:srgbClr val="94A3B8"/>
+                </a:solidFill>
+              </a:rPr>
+              <a:t>etc</a:t>
+            </a:r>
+            <a:r>
+              <a:rPr sz="950" dirty="0">
+                <a:solidFill>
+                  <a:srgbClr val="94A3B8"/>
+                </a:solidFill>
+              </a:rPr>
+              <a:t>/passwd) and maps to MITRE ATT&amp;CK T1059.</a:t>
+            </a:r>
+          </a:p>
+        </p:txBody>
+      </p:sp>
+      <p:pic>
+        <p:nvPicPr>
+          <p:cNvPr id="9" name="Picture 8">
+            <a:extLst>
+              <a:ext uri="{FF2B5EF4-FFF2-40B4-BE49-F238E27FC236}">
+                <a16:creationId xmlns:a16="http://schemas.microsoft.com/office/drawing/2014/main" id="{C1592B7D-0F4D-0681-A7E4-BC262350C6FE}"/>
+              </a:ext>
+            </a:extLst>
+          </p:cNvPr>
+          <p:cNvPicPr>
+            <a:picLocks noChangeAspect="1"/>
+          </p:cNvPicPr>
+          <p:nvPr/>
+        </p:nvPicPr>
+        <p:blipFill>
+          <a:blip r:embed="rId4"/>
+          <a:stretch>
+            <a:fillRect/>
+          </a:stretch>
+        </p:blipFill>
+        <p:spPr>
+          <a:xfrm>
+            <a:off x="118872" y="48690"/>
+            <a:ext cx="1570482" cy="507458"/>
+          </a:xfrm>
+          <a:prstGeom prst="rect">
+            <a:avLst/>
+          </a:prstGeom>
+        </p:spPr>
+      </p:pic>
     </p:spTree>
   </p:cSld>
   <p:clrMapOvr>
@@ -5125,7 +5723,7 @@
 </file>
 
 <file path=ppt/slides/slide6.xml><?xml version="1.0" encoding="utf-8"?>
-<p:sld xmlns:a="http://schemas.openxmlformats.org/drawingml/2006/main" xmlns:p="http://schemas.openxmlformats.org/presentationml/2006/main" xmlns:r="http://schemas.openxmlformats.org/officeDocument/2006/relationships">
+<p:sld xmlns:a="http://schemas.openxmlformats.org/drawingml/2006/main" xmlns:r="http://schemas.openxmlformats.org/officeDocument/2006/relationships" xmlns:p="http://schemas.openxmlformats.org/presentationml/2006/main">
   <p:cSld>
     <p:bg>
       <p:bgPr>
@@ -5141,40 +5739,14 @@
         <p:cNvGrpSpPr/>
         <p:nvPr/>
       </p:nvGrpSpPr>
-      <p:grpSpPr/>
-      <p:sp>
-        <p:nvSpPr>
-          <p:cNvPr id="2" name="TextBox 1"/>
-          <p:cNvSpPr txBox="1"/>
-          <p:nvPr/>
-        </p:nvSpPr>
-        <p:spPr>
-          <a:xfrm>
-            <a:off x="548640" y="228600"/>
-            <a:ext cx="10972800" cy="320040"/>
-          </a:xfrm>
-          <a:prstGeom prst="rect">
-            <a:avLst/>
-          </a:prstGeom>
-          <a:noFill/>
-        </p:spPr>
-        <p:txBody>
-          <a:bodyPr wrap="none">
-            <a:spAutoFit/>
-          </a:bodyPr>
-          <a:lstStyle/>
-          <a:p>
-            <a:r>
-              <a:rPr sz="1000" b="1">
-                <a:solidFill>
-                  <a:srgbClr val="10B981"/>
-                </a:solidFill>
-              </a:rPr>
-              <a:t>K.A.R.M.A CLOUD SIEM</a:t>
-            </a:r>
-          </a:p>
-        </p:txBody>
-      </p:sp>
+      <p:grpSpPr>
+        <a:xfrm>
+          <a:off x="0" y="0"/>
+          <a:ext cx="0" cy="0"/>
+          <a:chOff x="0" y="0"/>
+          <a:chExt cx="0" cy="0"/>
+        </a:xfrm>
+      </p:grpSpPr>
       <p:sp>
         <p:nvSpPr>
           <p:cNvPr id="3" name="TextBox 2"/>
@@ -5240,8 +5812,8 @@
         </p:nvSpPr>
         <p:spPr>
           <a:xfrm>
-            <a:off x="731520" y="1188720"/>
-            <a:ext cx="3474720" cy="1143000"/>
+            <a:off x="2788542" y="5806440"/>
+            <a:ext cx="2516886" cy="871650"/>
           </a:xfrm>
           <a:prstGeom prst="roundRect">
             <a:avLst/>
@@ -5270,7 +5842,7 @@
           </a:fontRef>
         </p:style>
         <p:txBody>
-          <a:bodyPr rtlCol="0" anchor="ctr" wrap="square"/>
+          <a:bodyPr wrap="square" rtlCol="0" anchor="ctr"/>
           <a:lstStyle/>
           <a:p>
             <a:pPr algn="ctr"/>
@@ -5304,8 +5876,8 @@
         </p:nvSpPr>
         <p:spPr>
           <a:xfrm>
-            <a:off x="7955279" y="1188720"/>
-            <a:ext cx="3474720" cy="1143000"/>
+            <a:off x="8854441" y="5806440"/>
+            <a:ext cx="2666999" cy="871651"/>
           </a:xfrm>
           <a:prstGeom prst="roundRect">
             <a:avLst/>
@@ -5334,7 +5906,7 @@
           </a:fontRef>
         </p:style>
         <p:txBody>
-          <a:bodyPr rtlCol="0" anchor="ctr" wrap="square"/>
+          <a:bodyPr wrap="square" rtlCol="0" anchor="ctr"/>
           <a:lstStyle/>
           <a:p>
             <a:pPr algn="ctr"/>
@@ -5368,8 +5940,8 @@
         </p:nvSpPr>
         <p:spPr>
           <a:xfrm>
-            <a:off x="4206240" y="5120640"/>
-            <a:ext cx="3840480" cy="1143000"/>
+            <a:off x="5528312" y="5806440"/>
+            <a:ext cx="3103245" cy="871651"/>
           </a:xfrm>
           <a:prstGeom prst="roundRect">
             <a:avLst/>
@@ -5398,12 +5970,12 @@
           </a:fontRef>
         </p:style>
         <p:txBody>
-          <a:bodyPr rtlCol="0" anchor="ctr" wrap="square"/>
+          <a:bodyPr wrap="square" rtlCol="0" anchor="ctr"/>
           <a:lstStyle/>
           <a:p>
             <a:pPr algn="ctr"/>
             <a:r>
-              <a:rPr sz="1100" b="1">
+              <a:rPr sz="1100" b="1" dirty="0">
                 <a:solidFill>
                   <a:srgbClr val="10B981"/>
                 </a:solidFill>
@@ -5414,7 +5986,7 @@
           </a:p>
           <a:p>
             <a:r>
-              <a:rPr sz="950">
+              <a:rPr sz="950" dirty="0">
                 <a:solidFill>
                   <a:srgbClr val="94A3B8"/>
                 </a:solidFill>
@@ -5424,6 +5996,36 @@
           </a:p>
         </p:txBody>
       </p:sp>
+      <p:pic>
+        <p:nvPicPr>
+          <p:cNvPr id="8" name="Picture 7">
+            <a:extLst>
+              <a:ext uri="{FF2B5EF4-FFF2-40B4-BE49-F238E27FC236}">
+                <a16:creationId xmlns:a16="http://schemas.microsoft.com/office/drawing/2014/main" id="{0533F0E8-BCB7-3681-AF74-777189E548D3}"/>
+              </a:ext>
+            </a:extLst>
+          </p:cNvPr>
+          <p:cNvPicPr>
+            <a:picLocks noChangeAspect="1"/>
+          </p:cNvPicPr>
+          <p:nvPr/>
+        </p:nvPicPr>
+        <p:blipFill>
+          <a:blip r:embed="rId3"/>
+          <a:stretch>
+            <a:fillRect/>
+          </a:stretch>
+        </p:blipFill>
+        <p:spPr>
+          <a:xfrm>
+            <a:off x="118872" y="48690"/>
+            <a:ext cx="1570482" cy="507458"/>
+          </a:xfrm>
+          <a:prstGeom prst="rect">
+            <a:avLst/>
+          </a:prstGeom>
+        </p:spPr>
+      </p:pic>
     </p:spTree>
   </p:cSld>
   <p:clrMapOvr>
@@ -5433,7 +6035,7 @@
 </file>
 
 <file path=ppt/slides/slide7.xml><?xml version="1.0" encoding="utf-8"?>
-<p:sld xmlns:a="http://schemas.openxmlformats.org/drawingml/2006/main" xmlns:p="http://schemas.openxmlformats.org/presentationml/2006/main" xmlns:r="http://schemas.openxmlformats.org/officeDocument/2006/relationships">
+<p:sld xmlns:a="http://schemas.openxmlformats.org/drawingml/2006/main" xmlns:r="http://schemas.openxmlformats.org/officeDocument/2006/relationships" xmlns:p="http://schemas.openxmlformats.org/presentationml/2006/main">
   <p:cSld>
     <p:bg>
       <p:bgPr>
@@ -5449,17 +6051,24 @@
         <p:cNvGrpSpPr/>
         <p:nvPr/>
       </p:nvGrpSpPr>
-      <p:grpSpPr/>
-      <p:sp>
-        <p:nvSpPr>
-          <p:cNvPr id="2" name="TextBox 1"/>
+      <p:grpSpPr>
+        <a:xfrm>
+          <a:off x="0" y="0"/>
+          <a:ext cx="0" cy="0"/>
+          <a:chOff x="0" y="0"/>
+          <a:chExt cx="0" cy="0"/>
+        </a:xfrm>
+      </p:grpSpPr>
+      <p:sp>
+        <p:nvSpPr>
+          <p:cNvPr id="3" name="TextBox 2"/>
           <p:cNvSpPr txBox="1"/>
           <p:nvPr/>
         </p:nvSpPr>
         <p:spPr>
           <a:xfrm>
-            <a:off x="548640" y="228600"/>
-            <a:ext cx="10972800" cy="320040"/>
+            <a:off x="1689354" y="53228"/>
+            <a:ext cx="5330571" cy="400110"/>
           </a:xfrm>
           <a:prstGeom prst="rect">
             <a:avLst/>
@@ -5467,46 +6076,13 @@
           <a:noFill/>
         </p:spPr>
         <p:txBody>
-          <a:bodyPr wrap="none">
+          <a:bodyPr wrap="square">
             <a:spAutoFit/>
           </a:bodyPr>
           <a:lstStyle/>
           <a:p>
             <a:r>
-              <a:rPr sz="1000" b="1">
-                <a:solidFill>
-                  <a:srgbClr val="10B981"/>
-                </a:solidFill>
-              </a:rPr>
-              <a:t>K.A.R.M.A CLOUD SIEM</a:t>
-            </a:r>
-          </a:p>
-        </p:txBody>
-      </p:sp>
-      <p:sp>
-        <p:nvSpPr>
-          <p:cNvPr id="3" name="TextBox 2"/>
-          <p:cNvSpPr txBox="1"/>
-          <p:nvPr/>
-        </p:nvSpPr>
-        <p:spPr>
-          <a:xfrm>
-            <a:off x="548640" y="502920"/>
-            <a:ext cx="10972800" cy="502920"/>
-          </a:xfrm>
-          <a:prstGeom prst="rect">
-            <a:avLst/>
-          </a:prstGeom>
-          <a:noFill/>
-        </p:spPr>
-        <p:txBody>
-          <a:bodyPr wrap="none">
-            <a:spAutoFit/>
-          </a:bodyPr>
-          <a:lstStyle/>
-          <a:p>
-            <a:r>
-              <a:rPr sz="2000" b="1">
+              <a:rPr sz="2000" b="1" dirty="0">
                 <a:solidFill>
                   <a:srgbClr val="F8FAFC"/>
                 </a:solidFill>
@@ -5532,7 +6108,7 @@
         </p:blipFill>
         <p:spPr>
           <a:xfrm>
-            <a:off x="548640" y="1051560"/>
+            <a:off x="548640" y="547841"/>
             <a:ext cx="11094415" cy="5440680"/>
           </a:xfrm>
           <a:prstGeom prst="rect">
@@ -5548,8 +6124,8 @@
         </p:nvSpPr>
         <p:spPr>
           <a:xfrm>
-            <a:off x="731520" y="1188720"/>
-            <a:ext cx="3474720" cy="1143000"/>
+            <a:off x="257175" y="5919254"/>
+            <a:ext cx="2701290" cy="787780"/>
           </a:xfrm>
           <a:prstGeom prst="roundRect">
             <a:avLst/>
@@ -5578,7 +6154,7 @@
           </a:fontRef>
         </p:style>
         <p:txBody>
-          <a:bodyPr rtlCol="0" anchor="ctr" wrap="square"/>
+          <a:bodyPr wrap="square" rtlCol="0" anchor="ctr"/>
           <a:lstStyle/>
           <a:p>
             <a:pPr algn="ctr"/>
@@ -5593,6 +6169,7 @@
             </a:r>
           </a:p>
           <a:p>
+            <a:pPr algn="ctr"/>
             <a:r>
               <a:rPr sz="950">
                 <a:solidFill>
@@ -5612,8 +6189,8 @@
         </p:nvSpPr>
         <p:spPr>
           <a:xfrm>
-            <a:off x="7955279" y="1188720"/>
-            <a:ext cx="3474720" cy="1143000"/>
+            <a:off x="3209925" y="5919254"/>
+            <a:ext cx="2828924" cy="787780"/>
           </a:xfrm>
           <a:prstGeom prst="roundRect">
             <a:avLst/>
@@ -5642,12 +6219,12 @@
           </a:fontRef>
         </p:style>
         <p:txBody>
-          <a:bodyPr rtlCol="0" anchor="ctr" wrap="square"/>
+          <a:bodyPr wrap="square" rtlCol="0" anchor="ctr"/>
           <a:lstStyle/>
           <a:p>
             <a:pPr algn="ctr"/>
             <a:r>
-              <a:rPr sz="1100" b="1">
+              <a:rPr sz="1100" b="1" dirty="0">
                 <a:solidFill>
                   <a:srgbClr val="F59E0B"/>
                 </a:solidFill>
@@ -5657,8 +6234,9 @@
             </a:r>
           </a:p>
           <a:p>
-            <a:r>
-              <a:rPr sz="950">
+            <a:pPr algn="ctr"/>
+            <a:r>
+              <a:rPr sz="950" dirty="0">
                 <a:solidFill>
                   <a:srgbClr val="94A3B8"/>
                 </a:solidFill>
@@ -5676,8 +6254,8 @@
         </p:nvSpPr>
         <p:spPr>
           <a:xfrm>
-            <a:off x="731520" y="5120640"/>
-            <a:ext cx="3474720" cy="1143000"/>
+            <a:off x="6290309" y="5919254"/>
+            <a:ext cx="2701290" cy="787781"/>
           </a:xfrm>
           <a:prstGeom prst="roundRect">
             <a:avLst/>
@@ -5706,7 +6284,7 @@
           </a:fontRef>
         </p:style>
         <p:txBody>
-          <a:bodyPr rtlCol="0" anchor="ctr" wrap="square"/>
+          <a:bodyPr wrap="square" rtlCol="0" anchor="ctr"/>
           <a:lstStyle/>
           <a:p>
             <a:pPr algn="ctr"/>
@@ -5721,6 +6299,7 @@
             </a:r>
           </a:p>
           <a:p>
+            <a:pPr algn="ctr"/>
             <a:r>
               <a:rPr sz="950">
                 <a:solidFill>
@@ -5740,8 +6319,8 @@
         </p:nvSpPr>
         <p:spPr>
           <a:xfrm>
-            <a:off x="7955279" y="5120640"/>
-            <a:ext cx="3474720" cy="1143000"/>
+            <a:off x="9243059" y="5919254"/>
+            <a:ext cx="2701290" cy="787780"/>
           </a:xfrm>
           <a:prstGeom prst="roundRect">
             <a:avLst/>
@@ -5770,12 +6349,12 @@
           </a:fontRef>
         </p:style>
         <p:txBody>
-          <a:bodyPr rtlCol="0" anchor="ctr" wrap="square"/>
+          <a:bodyPr wrap="square" rtlCol="0" anchor="ctr"/>
           <a:lstStyle/>
           <a:p>
             <a:pPr algn="ctr"/>
             <a:r>
-              <a:rPr sz="1100" b="1">
+              <a:rPr sz="1100" b="1" dirty="0">
                 <a:solidFill>
                   <a:srgbClr val="10B981"/>
                 </a:solidFill>
@@ -5785,8 +6364,9 @@
             </a:r>
           </a:p>
           <a:p>
-            <a:r>
-              <a:rPr sz="950">
+            <a:pPr algn="ctr"/>
+            <a:r>
+              <a:rPr sz="950" dirty="0">
                 <a:solidFill>
                   <a:srgbClr val="94A3B8"/>
                 </a:solidFill>
@@ -5796,6 +6376,36 @@
           </a:p>
         </p:txBody>
       </p:sp>
+      <p:pic>
+        <p:nvPicPr>
+          <p:cNvPr id="9" name="Picture 8">
+            <a:extLst>
+              <a:ext uri="{FF2B5EF4-FFF2-40B4-BE49-F238E27FC236}">
+                <a16:creationId xmlns:a16="http://schemas.microsoft.com/office/drawing/2014/main" id="{67117AE8-82BC-C9D2-3E95-8A9341F8B220}"/>
+              </a:ext>
+            </a:extLst>
+          </p:cNvPr>
+          <p:cNvPicPr>
+            <a:picLocks noChangeAspect="1"/>
+          </p:cNvPicPr>
+          <p:nvPr/>
+        </p:nvPicPr>
+        <p:blipFill>
+          <a:blip r:embed="rId3"/>
+          <a:stretch>
+            <a:fillRect/>
+          </a:stretch>
+        </p:blipFill>
+        <p:spPr>
+          <a:xfrm>
+            <a:off x="118872" y="48690"/>
+            <a:ext cx="1570482" cy="507458"/>
+          </a:xfrm>
+          <a:prstGeom prst="rect">
+            <a:avLst/>
+          </a:prstGeom>
+        </p:spPr>
+      </p:pic>
     </p:spTree>
   </p:cSld>
   <p:clrMapOvr>
@@ -5805,7 +6415,7 @@
 </file>
 
 <file path=ppt/slides/slide8.xml><?xml version="1.0" encoding="utf-8"?>
-<p:sld xmlns:a="http://schemas.openxmlformats.org/drawingml/2006/main" xmlns:p="http://schemas.openxmlformats.org/presentationml/2006/main" xmlns:r="http://schemas.openxmlformats.org/officeDocument/2006/relationships">
+<p:sld xmlns:a="http://schemas.openxmlformats.org/drawingml/2006/main" xmlns:r="http://schemas.openxmlformats.org/officeDocument/2006/relationships" xmlns:p="http://schemas.openxmlformats.org/presentationml/2006/main">
   <p:cSld>
     <p:bg>
       <p:bgPr>
@@ -5821,40 +6431,14 @@
         <p:cNvGrpSpPr/>
         <p:nvPr/>
       </p:nvGrpSpPr>
-      <p:grpSpPr/>
-      <p:sp>
-        <p:nvSpPr>
-          <p:cNvPr id="2" name="TextBox 1"/>
-          <p:cNvSpPr txBox="1"/>
-          <p:nvPr/>
-        </p:nvSpPr>
-        <p:spPr>
-          <a:xfrm>
-            <a:off x="548640" y="228600"/>
-            <a:ext cx="10972800" cy="320040"/>
-          </a:xfrm>
-          <a:prstGeom prst="rect">
-            <a:avLst/>
-          </a:prstGeom>
-          <a:noFill/>
-        </p:spPr>
-        <p:txBody>
-          <a:bodyPr wrap="none">
-            <a:spAutoFit/>
-          </a:bodyPr>
-          <a:lstStyle/>
-          <a:p>
-            <a:r>
-              <a:rPr sz="1000" b="1">
-                <a:solidFill>
-                  <a:srgbClr val="10B981"/>
-                </a:solidFill>
-              </a:rPr>
-              <a:t>K.A.R.M.A CLOUD SIEM</a:t>
-            </a:r>
-          </a:p>
-        </p:txBody>
-      </p:sp>
+      <p:grpSpPr>
+        <a:xfrm>
+          <a:off x="0" y="0"/>
+          <a:ext cx="0" cy="0"/>
+          <a:chOff x="0" y="0"/>
+          <a:chExt cx="0" cy="0"/>
+        </a:xfrm>
+      </p:grpSpPr>
       <p:sp>
         <p:nvSpPr>
           <p:cNvPr id="3" name="TextBox 2"/>
@@ -5916,7 +6500,7 @@
               </a:spcAft>
             </a:pPr>
             <a:r>
-              <a:rPr b="1" sz="1300">
+              <a:rPr sz="1300" b="1">
                 <a:solidFill>
                   <a:srgbClr val="0070F3"/>
                 </a:solidFill>
@@ -5939,7 +6523,7 @@
               </a:spcAft>
             </a:pPr>
             <a:r>
-              <a:rPr b="1" sz="1300">
+              <a:rPr sz="1300" b="1">
                 <a:solidFill>
                   <a:srgbClr val="0070F3"/>
                 </a:solidFill>
@@ -5962,7 +6546,7 @@
               </a:spcAft>
             </a:pPr>
             <a:r>
-              <a:rPr b="1" sz="1300">
+              <a:rPr sz="1300" b="1">
                 <a:solidFill>
                   <a:srgbClr val="0070F3"/>
                 </a:solidFill>
@@ -5985,7 +6569,7 @@
               </a:spcAft>
             </a:pPr>
             <a:r>
-              <a:rPr b="1" sz="1300">
+              <a:rPr sz="1300" b="1">
                 <a:solidFill>
                   <a:srgbClr val="0070F3"/>
                 </a:solidFill>
@@ -6003,6 +6587,36 @@
           </a:p>
         </p:txBody>
       </p:sp>
+      <p:pic>
+        <p:nvPicPr>
+          <p:cNvPr id="5" name="Picture 4">
+            <a:extLst>
+              <a:ext uri="{FF2B5EF4-FFF2-40B4-BE49-F238E27FC236}">
+                <a16:creationId xmlns:a16="http://schemas.microsoft.com/office/drawing/2014/main" id="{CE25DD2F-F579-FAA2-B344-427FB612FA4D}"/>
+              </a:ext>
+            </a:extLst>
+          </p:cNvPr>
+          <p:cNvPicPr>
+            <a:picLocks noChangeAspect="1"/>
+          </p:cNvPicPr>
+          <p:nvPr/>
+        </p:nvPicPr>
+        <p:blipFill>
+          <a:blip r:embed="rId2"/>
+          <a:stretch>
+            <a:fillRect/>
+          </a:stretch>
+        </p:blipFill>
+        <p:spPr>
+          <a:xfrm>
+            <a:off x="118872" y="48690"/>
+            <a:ext cx="1570482" cy="507458"/>
+          </a:xfrm>
+          <a:prstGeom prst="rect">
+            <a:avLst/>
+          </a:prstGeom>
+        </p:spPr>
+      </p:pic>
     </p:spTree>
   </p:cSld>
   <p:clrMapOvr>
@@ -6012,7 +6626,7 @@
 </file>
 
 <file path=ppt/slides/slide9.xml><?xml version="1.0" encoding="utf-8"?>
-<p:sld xmlns:a="http://schemas.openxmlformats.org/drawingml/2006/main" xmlns:p="http://schemas.openxmlformats.org/presentationml/2006/main" xmlns:r="http://schemas.openxmlformats.org/officeDocument/2006/relationships">
+<p:sld xmlns:a="http://schemas.openxmlformats.org/drawingml/2006/main" xmlns:r="http://schemas.openxmlformats.org/officeDocument/2006/relationships" xmlns:p="http://schemas.openxmlformats.org/presentationml/2006/main">
   <p:cSld>
     <p:bg>
       <p:bgPr>
@@ -6028,40 +6642,14 @@
         <p:cNvGrpSpPr/>
         <p:nvPr/>
       </p:nvGrpSpPr>
-      <p:grpSpPr/>
-      <p:sp>
-        <p:nvSpPr>
-          <p:cNvPr id="2" name="TextBox 1"/>
-          <p:cNvSpPr txBox="1"/>
-          <p:nvPr/>
-        </p:nvSpPr>
-        <p:spPr>
-          <a:xfrm>
-            <a:off x="548640" y="228600"/>
-            <a:ext cx="10972800" cy="320040"/>
-          </a:xfrm>
-          <a:prstGeom prst="rect">
-            <a:avLst/>
-          </a:prstGeom>
-          <a:noFill/>
-        </p:spPr>
-        <p:txBody>
-          <a:bodyPr wrap="none">
-            <a:spAutoFit/>
-          </a:bodyPr>
-          <a:lstStyle/>
-          <a:p>
-            <a:r>
-              <a:rPr sz="1000" b="1">
-                <a:solidFill>
-                  <a:srgbClr val="10B981"/>
-                </a:solidFill>
-              </a:rPr>
-              <a:t>K.A.R.M.A CLOUD SIEM</a:t>
-            </a:r>
-          </a:p>
-        </p:txBody>
-      </p:sp>
+      <p:grpSpPr>
+        <a:xfrm>
+          <a:off x="0" y="0"/>
+          <a:ext cx="0" cy="0"/>
+          <a:chOff x="0" y="0"/>
+          <a:chExt cx="0" cy="0"/>
+        </a:xfrm>
+      </p:grpSpPr>
       <p:sp>
         <p:nvSpPr>
           <p:cNvPr id="3" name="TextBox 2"/>
@@ -6127,8 +6715,8 @@
         </p:nvSpPr>
         <p:spPr>
           <a:xfrm>
-            <a:off x="731520" y="1188720"/>
-            <a:ext cx="3474720" cy="1143000"/>
+            <a:off x="1978989" y="5960744"/>
+            <a:ext cx="2844165" cy="788670"/>
           </a:xfrm>
           <a:prstGeom prst="roundRect">
             <a:avLst/>
@@ -6157,7 +6745,7 @@
           </a:fontRef>
         </p:style>
         <p:txBody>
-          <a:bodyPr rtlCol="0" anchor="ctr" wrap="square"/>
+          <a:bodyPr wrap="square" rtlCol="0" anchor="ctr"/>
           <a:lstStyle/>
           <a:p>
             <a:pPr algn="ctr"/>
@@ -6172,6 +6760,7 @@
             </a:r>
           </a:p>
           <a:p>
+            <a:pPr algn="ctr"/>
             <a:r>
               <a:rPr sz="950">
                 <a:solidFill>
@@ -6191,8 +6780,8 @@
         </p:nvSpPr>
         <p:spPr>
           <a:xfrm>
-            <a:off x="7955279" y="1188720"/>
-            <a:ext cx="3474720" cy="1143000"/>
+            <a:off x="8671256" y="5960744"/>
+            <a:ext cx="2971799" cy="788671"/>
           </a:xfrm>
           <a:prstGeom prst="roundRect">
             <a:avLst/>
@@ -6221,12 +6810,12 @@
           </a:fontRef>
         </p:style>
         <p:txBody>
-          <a:bodyPr rtlCol="0" anchor="ctr" wrap="square"/>
+          <a:bodyPr wrap="square" rtlCol="0" anchor="ctr"/>
           <a:lstStyle/>
           <a:p>
             <a:pPr algn="ctr"/>
             <a:r>
-              <a:rPr sz="1100" b="1">
+              <a:rPr sz="1100" b="1" dirty="0">
                 <a:solidFill>
                   <a:srgbClr val="10B981"/>
                 </a:solidFill>
@@ -6236,8 +6825,9 @@
             </a:r>
           </a:p>
           <a:p>
-            <a:r>
-              <a:rPr sz="950">
+            <a:pPr algn="ctr"/>
+            <a:r>
+              <a:rPr sz="950" dirty="0">
                 <a:solidFill>
                   <a:srgbClr val="94A3B8"/>
                 </a:solidFill>
@@ -6255,8 +6845,8 @@
         </p:nvSpPr>
         <p:spPr>
           <a:xfrm>
-            <a:off x="4206240" y="5120640"/>
-            <a:ext cx="3840480" cy="1143000"/>
+            <a:off x="5009845" y="5960744"/>
+            <a:ext cx="3474720" cy="788671"/>
           </a:xfrm>
           <a:prstGeom prst="roundRect">
             <a:avLst/>
@@ -6285,12 +6875,12 @@
           </a:fontRef>
         </p:style>
         <p:txBody>
-          <a:bodyPr rtlCol="0" anchor="ctr" wrap="square"/>
+          <a:bodyPr wrap="square" rtlCol="0" anchor="ctr"/>
           <a:lstStyle/>
           <a:p>
             <a:pPr algn="ctr"/>
             <a:r>
-              <a:rPr sz="1100" b="1">
+              <a:rPr sz="1100" b="1" dirty="0">
                 <a:solidFill>
                   <a:srgbClr val="0070F3"/>
                 </a:solidFill>
@@ -6300,8 +6890,9 @@
             </a:r>
           </a:p>
           <a:p>
-            <a:r>
-              <a:rPr sz="950">
+            <a:pPr algn="ctr"/>
+            <a:r>
+              <a:rPr sz="950" dirty="0">
                 <a:solidFill>
                   <a:srgbClr val="94A3B8"/>
                 </a:solidFill>
@@ -6311,6 +6902,36 @@
           </a:p>
         </p:txBody>
       </p:sp>
+      <p:pic>
+        <p:nvPicPr>
+          <p:cNvPr id="8" name="Picture 7">
+            <a:extLst>
+              <a:ext uri="{FF2B5EF4-FFF2-40B4-BE49-F238E27FC236}">
+                <a16:creationId xmlns:a16="http://schemas.microsoft.com/office/drawing/2014/main" id="{C43D85E4-9BF9-F2F4-7EBC-C1FE2E5F495E}"/>
+              </a:ext>
+            </a:extLst>
+          </p:cNvPr>
+          <p:cNvPicPr>
+            <a:picLocks noChangeAspect="1"/>
+          </p:cNvPicPr>
+          <p:nvPr/>
+        </p:nvPicPr>
+        <p:blipFill>
+          <a:blip r:embed="rId3"/>
+          <a:stretch>
+            <a:fillRect/>
+          </a:stretch>
+        </p:blipFill>
+        <p:spPr>
+          <a:xfrm>
+            <a:off x="118872" y="48690"/>
+            <a:ext cx="1570482" cy="507458"/>
+          </a:xfrm>
+          <a:prstGeom prst="rect">
+            <a:avLst/>
+          </a:prstGeom>
+        </p:spPr>
+      </p:pic>
     </p:spTree>
   </p:cSld>
   <p:clrMapOvr>
@@ -6637,4 +7258,319 @@
   </a:objectDefaults>
   <a:extraClrSchemeLst/>
 </a:theme>
+</file>
+
+<file path=ppt/theme/theme2.xml><?xml version="1.0" encoding="utf-8"?>
+<a:theme xmlns:a="http://schemas.openxmlformats.org/drawingml/2006/main" name="Office Theme">
+  <a:themeElements>
+    <a:clrScheme name="Office">
+      <a:dk1>
+        <a:sysClr val="windowText" lastClr="000000"/>
+      </a:dk1>
+      <a:lt1>
+        <a:sysClr val="window" lastClr="FFFFFF"/>
+      </a:lt1>
+      <a:dk2>
+        <a:srgbClr val="0E2841"/>
+      </a:dk2>
+      <a:lt2>
+        <a:srgbClr val="E8E8E8"/>
+      </a:lt2>
+      <a:accent1>
+        <a:srgbClr val="156082"/>
+      </a:accent1>
+      <a:accent2>
+        <a:srgbClr val="E97132"/>
+      </a:accent2>
+      <a:accent3>
+        <a:srgbClr val="196B24"/>
+      </a:accent3>
+      <a:accent4>
+        <a:srgbClr val="0F9ED5"/>
+      </a:accent4>
+      <a:accent5>
+        <a:srgbClr val="A02B93"/>
+      </a:accent5>
+      <a:accent6>
+        <a:srgbClr val="4EA72E"/>
+      </a:accent6>
+      <a:hlink>
+        <a:srgbClr val="467886"/>
+      </a:hlink>
+      <a:folHlink>
+        <a:srgbClr val="96607D"/>
+      </a:folHlink>
+    </a:clrScheme>
+    <a:fontScheme name="Office">
+      <a:majorFont>
+        <a:latin typeface="Aptos Display" panose="02110004020202020204"/>
+        <a:ea typeface=""/>
+        <a:cs typeface=""/>
+        <a:font script="Jpan" typeface="游ゴシック Light"/>
+        <a:font script="Hang" typeface="맑은 고딕"/>
+        <a:font script="Hans" typeface="等线 Light"/>
+        <a:font script="Hant" typeface="新細明體"/>
+        <a:font script="Arab" typeface="Times New Roman"/>
+        <a:font script="Hebr" typeface="Times New Roman"/>
+        <a:font script="Thai" typeface="Angsana New"/>
+        <a:font script="Ethi" typeface="Nyala"/>
+        <a:font script="Beng" typeface="Vrinda"/>
+        <a:font script="Gujr" typeface="Shruti"/>
+        <a:font script="Khmr" typeface="MoolBoran"/>
+        <a:font script="Knda" typeface="Tunga"/>
+        <a:font script="Guru" typeface="Raavi"/>
+        <a:font script="Cans" typeface="Euphemia"/>
+        <a:font script="Cher" typeface="Plantagenet Cherokee"/>
+        <a:font script="Yiii" typeface="Microsoft Yi Baiti"/>
+        <a:font script="Tibt" typeface="Microsoft Himalaya"/>
+        <a:font script="Thaa" typeface="MV Boli"/>
+        <a:font script="Deva" typeface="Mangal"/>
+        <a:font script="Telu" typeface="Gautami"/>
+        <a:font script="Taml" typeface="Latha"/>
+        <a:font script="Syrc" typeface="Estrangelo Edessa"/>
+        <a:font script="Orya" typeface="Kalinga"/>
+        <a:font script="Mlym" typeface="Kartika"/>
+        <a:font script="Laoo" typeface="DokChampa"/>
+        <a:font script="Sinh" typeface="Iskoola Pota"/>
+        <a:font script="Mong" typeface="Mongolian Baiti"/>
+        <a:font script="Viet" typeface="Times New Roman"/>
+        <a:font script="Uigh" typeface="Microsoft Uighur"/>
+        <a:font script="Geor" typeface="Sylfaen"/>
+        <a:font script="Armn" typeface="Arial"/>
+        <a:font script="Bugi" typeface="Leelawadee UI"/>
+        <a:font script="Bopo" typeface="Microsoft JhengHei"/>
+        <a:font script="Java" typeface="Javanese Text"/>
+        <a:font script="Lisu" typeface="Segoe UI"/>
+        <a:font script="Mymr" typeface="Myanmar Text"/>
+        <a:font script="Nkoo" typeface="Ebrima"/>
+        <a:font script="Olck" typeface="Nirmala UI"/>
+        <a:font script="Osma" typeface="Ebrima"/>
+        <a:font script="Phag" typeface="Phagspa"/>
+        <a:font script="Syrn" typeface="Estrangelo Edessa"/>
+        <a:font script="Syrj" typeface="Estrangelo Edessa"/>
+        <a:font script="Syre" typeface="Estrangelo Edessa"/>
+        <a:font script="Sora" typeface="Nirmala UI"/>
+        <a:font script="Tale" typeface="Microsoft Tai Le"/>
+        <a:font script="Talu" typeface="Microsoft New Tai Lue"/>
+        <a:font script="Tfng" typeface="Ebrima"/>
+      </a:majorFont>
+      <a:minorFont>
+        <a:latin typeface="Aptos" panose="02110004020202020204"/>
+        <a:ea typeface=""/>
+        <a:cs typeface=""/>
+        <a:font script="Jpan" typeface="游ゴシック"/>
+        <a:font script="Hang" typeface="맑은 고딕"/>
+        <a:font script="Hans" typeface="等线"/>
+        <a:font script="Hant" typeface="新細明體"/>
+        <a:font script="Arab" typeface="Arial"/>
+        <a:font script="Hebr" typeface="Arial"/>
+        <a:font script="Thai" typeface="Cordia New"/>
+        <a:font script="Ethi" typeface="Nyala"/>
+        <a:font script="Beng" typeface="Vrinda"/>
+        <a:font script="Gujr" typeface="Shruti"/>
+        <a:font script="Khmr" typeface="DaunPenh"/>
+        <a:font script="Knda" typeface="Tunga"/>
+        <a:font script="Guru" typeface="Raavi"/>
+        <a:font script="Cans" typeface="Euphemia"/>
+        <a:font script="Cher" typeface="Plantagenet Cherokee"/>
+        <a:font script="Yiii" typeface="Microsoft Yi Baiti"/>
+        <a:font script="Tibt" typeface="Microsoft Himalaya"/>
+        <a:font script="Thaa" typeface="MV Boli"/>
+        <a:font script="Deva" typeface="Mangal"/>
+        <a:font script="Telu" typeface="Gautami"/>
+        <a:font script="Taml" typeface="Latha"/>
+        <a:font script="Syrc" typeface="Estrangelo Edessa"/>
+        <a:font script="Orya" typeface="Kalinga"/>
+        <a:font script="Mlym" typeface="Kartika"/>
+        <a:font script="Laoo" typeface="DokChampa"/>
+        <a:font script="Sinh" typeface="Iskoola Pota"/>
+        <a:font script="Mong" typeface="Mongolian Baiti"/>
+        <a:font script="Viet" typeface="Arial"/>
+        <a:font script="Uigh" typeface="Microsoft Uighur"/>
+        <a:font script="Geor" typeface="Sylfaen"/>
+        <a:font script="Armn" typeface="Arial"/>
+        <a:font script="Bugi" typeface="Leelawadee UI"/>
+        <a:font script="Bopo" typeface="Microsoft JhengHei"/>
+        <a:font script="Java" typeface="Javanese Text"/>
+        <a:font script="Lisu" typeface="Segoe UI"/>
+        <a:font script="Mymr" typeface="Myanmar Text"/>
+        <a:font script="Nkoo" typeface="Ebrima"/>
+        <a:font script="Olck" typeface="Nirmala UI"/>
+        <a:font script="Osma" typeface="Ebrima"/>
+        <a:font script="Phag" typeface="Phagspa"/>
+        <a:font script="Syrn" typeface="Estrangelo Edessa"/>
+        <a:font script="Syrj" typeface="Estrangelo Edessa"/>
+        <a:font script="Syre" typeface="Estrangelo Edessa"/>
+        <a:font script="Sora" typeface="Nirmala UI"/>
+        <a:font script="Tale" typeface="Microsoft Tai Le"/>
+        <a:font script="Talu" typeface="Microsoft New Tai Lue"/>
+        <a:font script="Tfng" typeface="Ebrima"/>
+      </a:minorFont>
+    </a:fontScheme>
+    <a:fmtScheme name="Office">
+      <a:fillStyleLst>
+        <a:solidFill>
+          <a:schemeClr val="phClr"/>
+        </a:solidFill>
+        <a:gradFill rotWithShape="1">
+          <a:gsLst>
+            <a:gs pos="0">
+              <a:schemeClr val="phClr">
+                <a:lumMod val="110000"/>
+                <a:satMod val="105000"/>
+                <a:tint val="67000"/>
+              </a:schemeClr>
+            </a:gs>
+            <a:gs pos="50000">
+              <a:schemeClr val="phClr">
+                <a:lumMod val="105000"/>
+                <a:satMod val="103000"/>
+                <a:tint val="73000"/>
+              </a:schemeClr>
+            </a:gs>
+            <a:gs pos="100000">
+              <a:schemeClr val="phClr">
+                <a:lumMod val="105000"/>
+                <a:satMod val="109000"/>
+                <a:tint val="81000"/>
+              </a:schemeClr>
+            </a:gs>
+          </a:gsLst>
+          <a:lin ang="5400000" scaled="0"/>
+        </a:gradFill>
+        <a:gradFill rotWithShape="1">
+          <a:gsLst>
+            <a:gs pos="0">
+              <a:schemeClr val="phClr">
+                <a:satMod val="103000"/>
+                <a:lumMod val="102000"/>
+                <a:tint val="94000"/>
+              </a:schemeClr>
+            </a:gs>
+            <a:gs pos="50000">
+              <a:schemeClr val="phClr">
+                <a:satMod val="110000"/>
+                <a:lumMod val="100000"/>
+                <a:shade val="100000"/>
+              </a:schemeClr>
+            </a:gs>
+            <a:gs pos="100000">
+              <a:schemeClr val="phClr">
+                <a:lumMod val="99000"/>
+                <a:satMod val="120000"/>
+                <a:shade val="78000"/>
+              </a:schemeClr>
+            </a:gs>
+          </a:gsLst>
+          <a:lin ang="5400000" scaled="0"/>
+        </a:gradFill>
+      </a:fillStyleLst>
+      <a:lnStyleLst>
+        <a:ln w="12700" cap="flat" cmpd="sng" algn="ctr">
+          <a:solidFill>
+            <a:schemeClr val="phClr"/>
+          </a:solidFill>
+          <a:prstDash val="solid"/>
+          <a:miter lim="800000"/>
+        </a:ln>
+        <a:ln w="19050" cap="flat" cmpd="sng" algn="ctr">
+          <a:solidFill>
+            <a:schemeClr val="phClr"/>
+          </a:solidFill>
+          <a:prstDash val="solid"/>
+          <a:miter lim="800000"/>
+        </a:ln>
+        <a:ln w="25400" cap="flat" cmpd="sng" algn="ctr">
+          <a:solidFill>
+            <a:schemeClr val="phClr"/>
+          </a:solidFill>
+          <a:prstDash val="solid"/>
+          <a:miter lim="800000"/>
+        </a:ln>
+      </a:lnStyleLst>
+      <a:effectStyleLst>
+        <a:effectStyle>
+          <a:effectLst/>
+        </a:effectStyle>
+        <a:effectStyle>
+          <a:effectLst/>
+        </a:effectStyle>
+        <a:effectStyle>
+          <a:effectLst>
+            <a:outerShdw blurRad="57150" dist="19050" dir="5400000" algn="ctr" rotWithShape="0">
+              <a:srgbClr val="000000">
+                <a:alpha val="63000"/>
+              </a:srgbClr>
+            </a:outerShdw>
+          </a:effectLst>
+        </a:effectStyle>
+      </a:effectStyleLst>
+      <a:bgFillStyleLst>
+        <a:solidFill>
+          <a:schemeClr val="phClr"/>
+        </a:solidFill>
+        <a:solidFill>
+          <a:schemeClr val="phClr">
+            <a:tint val="95000"/>
+            <a:satMod val="170000"/>
+          </a:schemeClr>
+        </a:solidFill>
+        <a:gradFill rotWithShape="1">
+          <a:gsLst>
+            <a:gs pos="0">
+              <a:schemeClr val="phClr">
+                <a:tint val="93000"/>
+                <a:satMod val="150000"/>
+                <a:shade val="98000"/>
+                <a:lumMod val="102000"/>
+              </a:schemeClr>
+            </a:gs>
+            <a:gs pos="50000">
+              <a:schemeClr val="phClr">
+                <a:tint val="98000"/>
+                <a:satMod val="130000"/>
+                <a:shade val="90000"/>
+                <a:lumMod val="103000"/>
+              </a:schemeClr>
+            </a:gs>
+            <a:gs pos="100000">
+              <a:schemeClr val="phClr">
+                <a:shade val="63000"/>
+                <a:satMod val="120000"/>
+              </a:schemeClr>
+            </a:gs>
+          </a:gsLst>
+          <a:lin ang="5400000" scaled="0"/>
+        </a:gradFill>
+      </a:bgFillStyleLst>
+    </a:fmtScheme>
+  </a:themeElements>
+  <a:objectDefaults>
+    <a:lnDef>
+      <a:spPr/>
+      <a:bodyPr/>
+      <a:lstStyle/>
+      <a:style>
+        <a:lnRef idx="2">
+          <a:schemeClr val="accent1"/>
+        </a:lnRef>
+        <a:fillRef idx="0">
+          <a:schemeClr val="accent1"/>
+        </a:fillRef>
+        <a:effectRef idx="1">
+          <a:schemeClr val="accent1"/>
+        </a:effectRef>
+        <a:fontRef idx="minor">
+          <a:schemeClr val="tx1"/>
+        </a:fontRef>
+      </a:style>
+    </a:lnDef>
+  </a:objectDefaults>
+  <a:extraClrSchemeLst/>
+  <a:extLst>
+    <a:ext uri="{05A4C25C-085E-4340-85A3-A5531E510DB2}">
+      <thm15:themeFamily xmlns:thm15="http://schemas.microsoft.com/office/thememl/2012/main" name="Office Theme" id="{2E142A2C-CD16-42D6-873A-C26D2A0506FA}" vid="{1BDDFF52-6CD6-40A5-AB3C-68EB2F1E4D0A}"/>
+    </a:ext>
+  </a:extLst>
+</a:theme>
 </file>
</xml_diff>